<commit_message>
Compact text on slides 04/07/08/09/14/15 to prevent overlap
- slide-04: fontSize 13 → 12, 説明文を要約
- slide-07: fontSize 13 → 12, Nova 制約章を短縮
- slide-08: 副次的貢献章をハイフン整列
- slide-09: fontSize 13 → 12, bullets を 1-2 行削る
- slide-14: 全 fontSize 13/14 → 12（数式アクセントのみ 13）
- slide-15: 全 fontSize 13/14 → 12（数式アクセントのみ 13）
</commit_message>
<xml_diff>
--- a/docs/pptx/hypernova-rinkou.pptx
+++ b/docs/pptx/hypernova-rinkou.pptx
@@ -6989,7 +6989,7 @@
         <p:spPr>
           <a:xfrm>
             <a:off x="393192" y="1225296"/>
-            <a:ext cx="8284464" cy="2103120"/>
+            <a:ext cx="8284464" cy="2286000"/>
           </a:xfrm>
           <a:prstGeom prst="rect">
             <a:avLst/>
@@ -7008,7 +7008,7 @@
               <a:buNone/>
             </a:pPr>
             <a:r>
-              <a:rPr lang="en-US" sz="1600" b="1" dirty="0">
+              <a:rPr lang="en-US" sz="1400" b="1" dirty="0">
                 <a:solidFill>
                   <a:srgbClr val="3E7EC7"/>
                 </a:solidFill>
@@ -7018,7 +7018,7 @@
               </a:rPr>
               <a:t>■  Incrementally Verifiable Computation (IVC) とは</a:t>
             </a:r>
-            <a:endParaRPr lang="en-US" sz="1600" dirty="0"/>
+            <a:endParaRPr lang="en-US" sz="1400" dirty="0"/>
           </a:p>
           <a:p>
             <a:pPr algn="l" indent="0" marL="0">
@@ -7028,7 +7028,7 @@
               <a:buNone/>
             </a:pPr>
             <a:r>
-              <a:rPr lang="en-US" sz="1600" dirty="0">
+              <a:rPr lang="en-US" sz="1400" dirty="0">
                 <a:solidFill>
                   <a:srgbClr val="000000"/>
                 </a:solidFill>
@@ -7046,7 +7046,7 @@
               <a:buNone/>
             </a:pPr>
             <a:r>
-              <a:rPr lang="en-US" sz="1600" dirty="0">
+              <a:rPr lang="en-US" sz="1400" dirty="0">
                 <a:solidFill>
                   <a:srgbClr val="000000"/>
                 </a:solidFill>
@@ -7063,7 +7063,7 @@
               <a:buNone/>
             </a:pPr>
             <a:r>
-              <a:rPr lang="en-US" sz="1300" b="1" i="1" dirty="0">
+              <a:rPr lang="en-US" sz="1200" b="1" i="1" dirty="0">
                 <a:solidFill>
                   <a:srgbClr val="000000"/>
                 </a:solidFill>
@@ -7080,7 +7080,7 @@
               <a:buNone/>
             </a:pPr>
             <a:r>
-              <a:rPr lang="en-US" sz="1300" dirty="0">
+              <a:rPr lang="en-US" sz="1200" dirty="0">
                 <a:solidFill>
                   <a:srgbClr val="000000"/>
                 </a:solidFill>
@@ -7097,7 +7097,7 @@
               <a:buNone/>
             </a:pPr>
             <a:r>
-              <a:rPr lang="en-US" sz="1300" i="1" dirty="0">
+              <a:rPr lang="en-US" sz="1200" i="1" dirty="0">
                 <a:solidFill>
                   <a:srgbClr val="000000"/>
                 </a:solidFill>
@@ -7114,7 +7114,7 @@
               <a:buNone/>
             </a:pPr>
             <a:r>
-              <a:rPr lang="en-US" sz="1300" dirty="0">
+              <a:rPr lang="en-US" sz="1200" dirty="0">
                 <a:solidFill>
                   <a:srgbClr val="000000"/>
                 </a:solidFill>
@@ -7124,7 +7124,7 @@
               </a:rPr>
               <a:t>) → (pk, vk).</a:t>
             </a:r>
-            <a:endParaRPr lang="en-US" sz="1600" dirty="0"/>
+            <a:endParaRPr lang="en-US" sz="1400" dirty="0"/>
           </a:p>
           <a:p>
             <a:pPr algn="l" indent="0" marL="0">
@@ -7134,7 +7134,7 @@
               <a:buNone/>
             </a:pPr>
             <a:r>
-              <a:rPr lang="en-US" sz="1600" dirty="0">
+              <a:rPr lang="en-US" sz="1400" dirty="0">
                 <a:solidFill>
                   <a:srgbClr val="000000"/>
                 </a:solidFill>
@@ -7151,7 +7151,7 @@
               <a:buNone/>
             </a:pPr>
             <a:r>
-              <a:rPr lang="en-US" sz="1300" b="1" i="1" dirty="0">
+              <a:rPr lang="en-US" sz="1200" b="1" i="1" dirty="0">
                 <a:solidFill>
                   <a:srgbClr val="000000"/>
                 </a:solidFill>
@@ -7168,7 +7168,7 @@
               <a:buNone/>
             </a:pPr>
             <a:r>
-              <a:rPr lang="en-US" sz="1300" dirty="0">
+              <a:rPr lang="en-US" sz="1200" dirty="0">
                 <a:solidFill>
                   <a:srgbClr val="000000"/>
                 </a:solidFill>
@@ -7176,7 +7176,7 @@
                 <a:ea typeface="Yu Gothic" pitchFamily="34" charset="-122"/>
                 <a:cs typeface="Yu Gothic" pitchFamily="34" charset="-120"/>
               </a:rPr>
-              <a:t> は各ステップの witness </a:t>
+              <a:t> は witness </a:t>
             </a:r>
             <a:pPr algn="l" indent="0" marL="0">
               <a:spcAft>
@@ -7185,7 +7185,7 @@
               <a:buNone/>
             </a:pPr>
             <a:r>
-              <a:rPr lang="en-US" sz="1300" i="1" dirty="0">
+              <a:rPr lang="en-US" sz="1200" i="1" dirty="0">
                 <a:solidFill>
                   <a:srgbClr val="000000"/>
                 </a:solidFill>
@@ -7202,7 +7202,7 @@
               <a:buNone/>
             </a:pPr>
             <a:r>
-              <a:rPr lang="en-US" sz="1300" dirty="0">
+              <a:rPr lang="en-US" sz="1200" dirty="0">
                 <a:solidFill>
                   <a:srgbClr val="000000"/>
                 </a:solidFill>
@@ -7210,7 +7210,7 @@
                 <a:ea typeface="Yu Gothic" pitchFamily="34" charset="-122"/>
                 <a:cs typeface="Yu Gothic" pitchFamily="34" charset="-120"/>
               </a:rPr>
-              <a:t>_i を渡されて </a:t>
+              <a:t>_i から </a:t>
             </a:r>
             <a:pPr algn="l" indent="0" marL="0">
               <a:spcAft>
@@ -7219,7 +7219,7 @@
               <a:buNone/>
             </a:pPr>
             <a:r>
-              <a:rPr lang="en-US" sz="1300" i="1" dirty="0">
+              <a:rPr lang="en-US" sz="1200" i="1" dirty="0">
                 <a:solidFill>
                   <a:srgbClr val="000000"/>
                 </a:solidFill>
@@ -7236,7 +7236,7 @@
               <a:buNone/>
             </a:pPr>
             <a:r>
-              <a:rPr lang="en-US" sz="1300" dirty="0">
+              <a:rPr lang="en-US" sz="1200" dirty="0">
                 <a:solidFill>
                   <a:srgbClr val="000000"/>
                 </a:solidFill>
@@ -7244,9 +7244,9 @@
                 <a:ea typeface="Yu Gothic" pitchFamily="34" charset="-122"/>
                 <a:cs typeface="Yu Gothic" pitchFamily="34" charset="-120"/>
               </a:rPr>
-              <a:t>_i を更新する:</a:t>
-            </a:r>
-            <a:endParaRPr lang="en-US" sz="1600" dirty="0"/>
+              <a:t>_i を更新:</a:t>
+            </a:r>
+            <a:endParaRPr lang="en-US" sz="1400" dirty="0"/>
           </a:p>
           <a:p>
             <a:pPr algn="l" indent="0" marL="0">
@@ -7256,7 +7256,7 @@
               <a:buNone/>
             </a:pPr>
             <a:r>
-              <a:rPr lang="en-US" sz="1600" dirty="0">
+              <a:rPr lang="en-US" sz="1400" dirty="0">
                 <a:solidFill>
                   <a:srgbClr val="000000"/>
                 </a:solidFill>
@@ -7273,7 +7273,7 @@
               <a:buNone/>
             </a:pPr>
             <a:r>
-              <a:rPr lang="en-US" sz="1400" b="1" i="1" dirty="0">
+              <a:rPr lang="en-US" sz="1200" b="1" i="1" dirty="0">
                 <a:solidFill>
                   <a:srgbClr val="3E7EC7"/>
                 </a:solidFill>
@@ -7290,7 +7290,7 @@
               <a:buNone/>
             </a:pPr>
             <a:r>
-              <a:rPr lang="en-US" sz="1400" dirty="0">
+              <a:rPr lang="en-US" sz="1200" dirty="0">
                 <a:solidFill>
                   <a:srgbClr val="000000"/>
                 </a:solidFill>
@@ -7307,7 +7307,7 @@
               <a:buNone/>
             </a:pPr>
             <a:r>
-              <a:rPr lang="en-US" sz="1400" i="1" dirty="0">
+              <a:rPr lang="en-US" sz="1200" i="1" dirty="0">
                 <a:solidFill>
                   <a:srgbClr val="000000"/>
                 </a:solidFill>
@@ -7324,7 +7324,7 @@
               <a:buNone/>
             </a:pPr>
             <a:r>
-              <a:rPr lang="en-US" sz="1400" dirty="0">
+              <a:rPr lang="en-US" sz="1200" dirty="0">
                 <a:solidFill>
                   <a:srgbClr val="000000"/>
                 </a:solidFill>
@@ -7334,7 +7334,7 @@
               </a:rPr>
               <a:t>(pk, F, z_0, i, (z_1, ω_1), …, (z_i, ω_i))</a:t>
             </a:r>
-            <a:endParaRPr lang="en-US" sz="1600" dirty="0"/>
+            <a:endParaRPr lang="en-US" sz="1400" dirty="0"/>
           </a:p>
           <a:p>
             <a:pPr algn="l" indent="0" marL="0">
@@ -7344,7 +7344,7 @@
               <a:buNone/>
             </a:pPr>
             <a:r>
-              <a:rPr lang="en-US" sz="1600" dirty="0">
+              <a:rPr lang="en-US" sz="1400" dirty="0">
                 <a:solidFill>
                   <a:srgbClr val="000000"/>
                 </a:solidFill>
@@ -7361,7 +7361,7 @@
               <a:buNone/>
             </a:pPr>
             <a:r>
-              <a:rPr lang="en-US" sz="1300" b="1" i="1" dirty="0">
+              <a:rPr lang="en-US" sz="1200" b="1" i="1" dirty="0">
                 <a:solidFill>
                   <a:srgbClr val="000000"/>
                 </a:solidFill>
@@ -7378,7 +7378,7 @@
               <a:buNone/>
             </a:pPr>
             <a:r>
-              <a:rPr lang="en-US" sz="1300" dirty="0">
+              <a:rPr lang="en-US" sz="1200" dirty="0">
                 <a:solidFill>
                   <a:srgbClr val="000000"/>
                 </a:solidFill>
@@ -7388,7 +7388,7 @@
               </a:rPr>
               <a:t> は最終 π だけ見て判定:</a:t>
             </a:r>
-            <a:endParaRPr lang="en-US" sz="1600" dirty="0"/>
+            <a:endParaRPr lang="en-US" sz="1400" dirty="0"/>
           </a:p>
           <a:p>
             <a:pPr algn="l" indent="0" marL="0">
@@ -7398,7 +7398,7 @@
               <a:buNone/>
             </a:pPr>
             <a:r>
-              <a:rPr lang="en-US" sz="1600" dirty="0">
+              <a:rPr lang="en-US" sz="1400" dirty="0">
                 <a:solidFill>
                   <a:srgbClr val="000000"/>
                 </a:solidFill>
@@ -7415,7 +7415,7 @@
               <a:buNone/>
             </a:pPr>
             <a:r>
-              <a:rPr lang="en-US" sz="1400" i="1" dirty="0">
+              <a:rPr lang="en-US" sz="1200" i="1" dirty="0">
                 <a:solidFill>
                   <a:srgbClr val="000000"/>
                 </a:solidFill>
@@ -7432,7 +7432,7 @@
               <a:buNone/>
             </a:pPr>
             <a:r>
-              <a:rPr lang="en-US" sz="1400" dirty="0">
+              <a:rPr lang="en-US" sz="1200" dirty="0">
                 <a:solidFill>
                   <a:srgbClr val="000000"/>
                 </a:solidFill>
@@ -7449,7 +7449,7 @@
               <a:buNone/>
             </a:pPr>
             <a:r>
-              <a:rPr lang="en-US" sz="1400" b="1" i="1" dirty="0">
+              <a:rPr lang="en-US" sz="1200" b="1" i="1" dirty="0">
                 <a:solidFill>
                   <a:srgbClr val="3E7EC7"/>
                 </a:solidFill>
@@ -7466,7 +7466,7 @@
               <a:buNone/>
             </a:pPr>
             <a:r>
-              <a:rPr lang="en-US" sz="1600" dirty="0">
+              <a:rPr lang="en-US" sz="1400" dirty="0">
                 <a:solidFill>
                   <a:srgbClr val="000000"/>
                 </a:solidFill>
@@ -7484,7 +7484,7 @@
               <a:buNone/>
             </a:pPr>
             <a:r>
-              <a:rPr lang="en-US" sz="1300" dirty="0">
+              <a:rPr lang="en-US" sz="1200" dirty="0">
                 <a:solidFill>
                   <a:srgbClr val="6B7280"/>
                 </a:solidFill>
@@ -7501,7 +7501,7 @@
               <a:buNone/>
             </a:pPr>
             <a:r>
-              <a:rPr lang="en-US" sz="1300" i="1" dirty="0">
+              <a:rPr lang="en-US" sz="1200" i="1" dirty="0">
                 <a:solidFill>
                   <a:srgbClr val="000000"/>
                 </a:solidFill>
@@ -7518,7 +7518,7 @@
               <a:buNone/>
             </a:pPr>
             <a:r>
-              <a:rPr lang="en-US" sz="1300" dirty="0">
+              <a:rPr lang="en-US" sz="1200" dirty="0">
                 <a:solidFill>
                   <a:srgbClr val="6B7280"/>
                 </a:solidFill>
@@ -7535,7 +7535,7 @@
               <a:buNone/>
             </a:pPr>
             <a:r>
-              <a:rPr lang="en-US" sz="1300" i="1" dirty="0">
+              <a:rPr lang="en-US" sz="1200" i="1" dirty="0">
                 <a:solidFill>
                   <a:srgbClr val="000000"/>
                 </a:solidFill>
@@ -7552,7 +7552,7 @@
               <a:buNone/>
             </a:pPr>
             <a:r>
-              <a:rPr lang="en-US" sz="1300" dirty="0">
+              <a:rPr lang="en-US" sz="1200" dirty="0">
                 <a:solidFill>
                   <a:srgbClr val="6B7280"/>
                 </a:solidFill>
@@ -7569,7 +7569,7 @@
               <a:buNone/>
             </a:pPr>
             <a:r>
-              <a:rPr lang="en-US" sz="1300" b="1" i="1" dirty="0">
+              <a:rPr lang="en-US" sz="1200" b="1" i="1" dirty="0">
                 <a:solidFill>
                   <a:srgbClr val="3E7EC7"/>
                 </a:solidFill>
@@ -7579,7 +7579,7 @@
               </a:rPr>
               <a:t>ZK (Hiding)</a:t>
             </a:r>
-            <a:endParaRPr lang="en-US" sz="1600" dirty="0"/>
+            <a:endParaRPr lang="en-US" sz="1400" dirty="0"/>
           </a:p>
         </p:txBody>
       </p:sp>
@@ -7591,7 +7591,7 @@
         </p:nvSpPr>
         <p:spPr>
           <a:xfrm>
-            <a:off x="393192" y="3429000"/>
+            <a:off x="393192" y="3611880"/>
             <a:ext cx="8284464" cy="0"/>
           </a:xfrm>
           <a:prstGeom prst="line">
@@ -7614,8 +7614,8 @@
         </p:nvSpPr>
         <p:spPr>
           <a:xfrm>
-            <a:off x="393192" y="3611880"/>
-            <a:ext cx="8284464" cy="2606040"/>
+            <a:off x="393192" y="3749040"/>
+            <a:ext cx="8284464" cy="2468880"/>
           </a:xfrm>
           <a:prstGeom prst="rect">
             <a:avLst/>
@@ -7634,7 +7634,7 @@
               <a:buNone/>
             </a:pPr>
             <a:r>
-              <a:rPr lang="en-US" sz="1600" b="1" dirty="0">
+              <a:rPr lang="en-US" sz="1400" b="1" dirty="0">
                 <a:solidFill>
                   <a:srgbClr val="3E7EC7"/>
                 </a:solidFill>
@@ -7644,7 +7644,7 @@
               </a:rPr>
               <a:t>■  Folding Scheme とは</a:t>
             </a:r>
-            <a:endParaRPr lang="en-US" sz="1600" dirty="0"/>
+            <a:endParaRPr lang="en-US" sz="1400" dirty="0"/>
           </a:p>
           <a:p>
             <a:pPr algn="l" indent="0" marL="0">
@@ -7654,7 +7654,7 @@
               <a:buNone/>
             </a:pPr>
             <a:r>
-              <a:rPr lang="en-US" sz="1600" dirty="0">
+              <a:rPr lang="en-US" sz="1400" dirty="0">
                 <a:solidFill>
                   <a:srgbClr val="000000"/>
                 </a:solidFill>
@@ -7672,7 +7672,7 @@
               <a:buNone/>
             </a:pPr>
             <a:r>
-              <a:rPr lang="en-US" sz="1300" dirty="0">
+              <a:rPr lang="en-US" sz="1200" dirty="0">
                 <a:solidFill>
                   <a:srgbClr val="000000"/>
                 </a:solidFill>
@@ -7682,7 +7682,7 @@
               </a:rPr>
               <a:t>  ◾ 2 つの NP instance を 1 つの instance に集約する暗号プリミティブ</a:t>
             </a:r>
-            <a:endParaRPr lang="en-US" sz="1600" dirty="0"/>
+            <a:endParaRPr lang="en-US" sz="1400" dirty="0"/>
           </a:p>
           <a:p>
             <a:pPr algn="l" indent="0" marL="0">
@@ -7692,7 +7692,7 @@
               <a:buNone/>
             </a:pPr>
             <a:r>
-              <a:rPr lang="en-US" sz="1600" dirty="0">
+              <a:rPr lang="en-US" sz="1400" dirty="0">
                 <a:solidFill>
                   <a:srgbClr val="000000"/>
                 </a:solidFill>
@@ -7709,7 +7709,7 @@
               <a:buNone/>
             </a:pPr>
             <a:r>
-              <a:rPr lang="en-US" sz="1400" b="1" dirty="0">
+              <a:rPr lang="en-US" sz="1300" b="1" dirty="0">
                 <a:solidFill>
                   <a:srgbClr val="3E7EC7"/>
                 </a:solidFill>
@@ -7719,7 +7719,7 @@
               </a:rPr>
               <a:t>(u_1, u_2)  ── Fold ──→  u_3</a:t>
             </a:r>
-            <a:endParaRPr lang="en-US" sz="1600" dirty="0"/>
+            <a:endParaRPr lang="en-US" sz="1400" dirty="0"/>
           </a:p>
           <a:p>
             <a:pPr algn="l" indent="0" marL="0">
@@ -7729,7 +7729,7 @@
               <a:buNone/>
             </a:pPr>
             <a:r>
-              <a:rPr lang="en-US" sz="1300" dirty="0">
+              <a:rPr lang="en-US" sz="1200" dirty="0">
                 <a:solidFill>
                   <a:srgbClr val="000000"/>
                 </a:solidFill>
@@ -7739,7 +7739,7 @@
               </a:rPr>
               <a:t>  ◾ Prover と Verifier の動作:</a:t>
             </a:r>
-            <a:endParaRPr lang="en-US" sz="1600" dirty="0"/>
+            <a:endParaRPr lang="en-US" sz="1400" dirty="0"/>
           </a:p>
           <a:p>
             <a:pPr algn="l" indent="0" marL="0">
@@ -7749,7 +7749,7 @@
               <a:buNone/>
             </a:pPr>
             <a:r>
-              <a:rPr lang="en-US" sz="1600" dirty="0">
+              <a:rPr lang="en-US" sz="1400" dirty="0">
                 <a:solidFill>
                   <a:srgbClr val="000000"/>
                 </a:solidFill>
@@ -7766,7 +7766,7 @@
               <a:buNone/>
             </a:pPr>
             <a:r>
-              <a:rPr lang="en-US" sz="1300" i="1" dirty="0">
+              <a:rPr lang="en-US" sz="1200" i="1" dirty="0">
                 <a:solidFill>
                   <a:srgbClr val="000000"/>
                 </a:solidFill>
@@ -7783,7 +7783,7 @@
               <a:buNone/>
             </a:pPr>
             <a:r>
-              <a:rPr lang="en-US" sz="1300" dirty="0">
+              <a:rPr lang="en-US" sz="1200" dirty="0">
                 <a:solidFill>
                   <a:srgbClr val="000000"/>
                 </a:solidFill>
@@ -7800,7 +7800,7 @@
               <a:buNone/>
             </a:pPr>
             <a:r>
-              <a:rPr lang="en-US" sz="1300" i="1" dirty="0">
+              <a:rPr lang="en-US" sz="1200" i="1" dirty="0">
                 <a:solidFill>
                   <a:srgbClr val="000000"/>
                 </a:solidFill>
@@ -7817,7 +7817,7 @@
               <a:buNone/>
             </a:pPr>
             <a:r>
-              <a:rPr lang="en-US" sz="1300" dirty="0">
+              <a:rPr lang="en-US" sz="1200" dirty="0">
                 <a:solidFill>
                   <a:srgbClr val="000000"/>
                 </a:solidFill>
@@ -7825,9 +7825,9 @@
                 <a:ea typeface="Yu Gothic" pitchFamily="34" charset="-122"/>
                 <a:cs typeface="Yu Gothic" pitchFamily="34" charset="-120"/>
               </a:rPr>
-              <a:t>_3      (folded proof)</a:t>
-            </a:r>
-            <a:endParaRPr lang="en-US" sz="1600" dirty="0"/>
+              <a:t>_3  (folded proof)</a:t>
+            </a:r>
+            <a:endParaRPr lang="en-US" sz="1400" dirty="0"/>
           </a:p>
           <a:p>
             <a:pPr algn="l" indent="0" marL="0">
@@ -7837,7 +7837,7 @@
               <a:buNone/>
             </a:pPr>
             <a:r>
-              <a:rPr lang="en-US" sz="1600" dirty="0">
+              <a:rPr lang="en-US" sz="1400" dirty="0">
                 <a:solidFill>
                   <a:srgbClr val="000000"/>
                 </a:solidFill>
@@ -7854,7 +7854,7 @@
               <a:buNone/>
             </a:pPr>
             <a:r>
-              <a:rPr lang="en-US" sz="1300" i="1" dirty="0">
+              <a:rPr lang="en-US" sz="1200" i="1" dirty="0">
                 <a:solidFill>
                   <a:srgbClr val="000000"/>
                 </a:solidFill>
@@ -7871,7 +7871,7 @@
               <a:buNone/>
             </a:pPr>
             <a:r>
-              <a:rPr lang="en-US" sz="1300" dirty="0">
+              <a:rPr lang="en-US" sz="1200" dirty="0">
                 <a:solidFill>
                   <a:srgbClr val="000000"/>
                 </a:solidFill>
@@ -7888,7 +7888,7 @@
               <a:buNone/>
             </a:pPr>
             <a:r>
-              <a:rPr lang="en-US" sz="1300" b="1" i="1" dirty="0">
+              <a:rPr lang="en-US" sz="1200" b="1" i="1" dirty="0">
                 <a:solidFill>
                   <a:srgbClr val="3E7EC7"/>
                 </a:solidFill>
@@ -7905,7 +7905,7 @@
               <a:buNone/>
             </a:pPr>
             <a:r>
-              <a:rPr lang="en-US" sz="1600" dirty="0">
+              <a:rPr lang="en-US" sz="1400" dirty="0">
                 <a:solidFill>
                   <a:srgbClr val="000000"/>
                 </a:solidFill>
@@ -7923,7 +7923,7 @@
               <a:buNone/>
             </a:pPr>
             <a:r>
-              <a:rPr lang="en-US" sz="1300" dirty="0">
+              <a:rPr lang="en-US" sz="1200" dirty="0">
                 <a:solidFill>
                   <a:srgbClr val="000000"/>
                 </a:solidFill>
@@ -7933,7 +7933,7 @@
               </a:rPr>
               <a:t>  ◾ Folding のコスト:</a:t>
             </a:r>
-            <a:endParaRPr lang="en-US" sz="1600" dirty="0"/>
+            <a:endParaRPr lang="en-US" sz="1400" dirty="0"/>
           </a:p>
           <a:p>
             <a:pPr algn="l" indent="0" marL="0">
@@ -7943,7 +7943,7 @@
               <a:buNone/>
             </a:pPr>
             <a:r>
-              <a:rPr lang="en-US" sz="1600" dirty="0">
+              <a:rPr lang="en-US" sz="1400" dirty="0">
                 <a:solidFill>
                   <a:srgbClr val="000000"/>
                 </a:solidFill>
@@ -7960,7 +7960,7 @@
               <a:buNone/>
             </a:pPr>
             <a:r>
-              <a:rPr lang="en-US" sz="1300" dirty="0">
+              <a:rPr lang="en-US" sz="1200" dirty="0">
                 <a:solidFill>
                   <a:srgbClr val="000000"/>
                 </a:solidFill>
@@ -7977,7 +7977,7 @@
               <a:buNone/>
             </a:pPr>
             <a:r>
-              <a:rPr lang="en-US" sz="1300" i="1" dirty="0">
+              <a:rPr lang="en-US" sz="1200" i="1" dirty="0">
                 <a:solidFill>
                   <a:srgbClr val="000000"/>
                 </a:solidFill>
@@ -7994,7 +7994,7 @@
               <a:buNone/>
             </a:pPr>
             <a:r>
-              <a:rPr lang="en-US" sz="1300" dirty="0">
+              <a:rPr lang="en-US" sz="1200" dirty="0">
                 <a:solidFill>
                   <a:srgbClr val="000000"/>
                 </a:solidFill>
@@ -8004,7 +8004,7 @@
               </a:rPr>
               <a:t> で 1 step を完了</a:t>
             </a:r>
-            <a:endParaRPr lang="en-US" sz="1600" dirty="0"/>
+            <a:endParaRPr lang="en-US" sz="1400" dirty="0"/>
           </a:p>
           <a:p>
             <a:pPr algn="l" indent="0" marL="0">
@@ -8014,7 +8014,7 @@
               <a:buNone/>
             </a:pPr>
             <a:r>
-              <a:rPr lang="en-US" sz="1600" dirty="0">
+              <a:rPr lang="en-US" sz="1400" dirty="0">
                 <a:solidFill>
                   <a:srgbClr val="000000"/>
                 </a:solidFill>
@@ -8031,7 +8031,7 @@
               <a:buNone/>
             </a:pPr>
             <a:r>
-              <a:rPr lang="en-US" sz="1300" dirty="0">
+              <a:rPr lang="en-US" sz="1200" dirty="0">
                 <a:solidFill>
                   <a:srgbClr val="000000"/>
                 </a:solidFill>
@@ -8048,7 +8048,7 @@
               <a:buNone/>
             </a:pPr>
             <a:r>
-              <a:rPr lang="en-US" sz="1400" b="1" i="1" dirty="0">
+              <a:rPr lang="en-US" sz="1300" b="1" i="1" dirty="0">
                 <a:solidFill>
                   <a:srgbClr val="3E7EC7"/>
                 </a:solidFill>
@@ -8065,7 +8065,7 @@
               <a:buNone/>
             </a:pPr>
             <a:r>
-              <a:rPr lang="en-US" sz="1300" dirty="0">
+              <a:rPr lang="en-US" sz="1200" dirty="0">
                 <a:solidFill>
                   <a:srgbClr val="000000"/>
                 </a:solidFill>
@@ -8082,7 +8082,7 @@
               <a:buNone/>
             </a:pPr>
             <a:r>
-              <a:rPr lang="en-US" sz="1300" i="1" dirty="0">
+              <a:rPr lang="en-US" sz="1200" i="1" dirty="0">
                 <a:solidFill>
                   <a:srgbClr val="000000"/>
                 </a:solidFill>
@@ -8099,7 +8099,7 @@
               <a:buNone/>
             </a:pPr>
             <a:r>
-              <a:rPr lang="en-US" sz="1300" dirty="0">
+              <a:rPr lang="en-US" sz="1200" dirty="0">
                 <a:solidFill>
                   <a:srgbClr val="000000"/>
                 </a:solidFill>
@@ -8109,7 +8109,7 @@
               </a:rPr>
               <a:t> は制約システムの変数数</a:t>
             </a:r>
-            <a:endParaRPr lang="en-US" sz="1600" dirty="0"/>
+            <a:endParaRPr lang="en-US" sz="1400" dirty="0"/>
           </a:p>
         </p:txBody>
       </p:sp>
@@ -8436,7 +8436,7 @@
         <p:spPr>
           <a:xfrm>
             <a:off x="393192" y="1225296"/>
-            <a:ext cx="8284464" cy="2377440"/>
+            <a:ext cx="8284464" cy="2331720"/>
           </a:xfrm>
           <a:prstGeom prst="rect">
             <a:avLst/>
@@ -8455,7 +8455,7 @@
               <a:buNone/>
             </a:pPr>
             <a:r>
-              <a:rPr lang="en-US" sz="1600" b="1" dirty="0">
+              <a:rPr lang="en-US" sz="1400" b="1" dirty="0">
                 <a:solidFill>
                   <a:srgbClr val="3E7EC7"/>
                 </a:solidFill>
@@ -8465,7 +8465,7 @@
               </a:rPr>
               <a:t>■  ZK-IVC (Zero-Knowledge IVC) とは</a:t>
             </a:r>
-            <a:endParaRPr lang="en-US" sz="1600" dirty="0"/>
+            <a:endParaRPr lang="en-US" sz="1400" dirty="0"/>
           </a:p>
           <a:p>
             <a:pPr algn="l" indent="0" marL="0">
@@ -8475,7 +8475,7 @@
               <a:buNone/>
             </a:pPr>
             <a:r>
-              <a:rPr lang="en-US" sz="1600" dirty="0">
+              <a:rPr lang="en-US" sz="1400" dirty="0">
                 <a:solidFill>
                   <a:srgbClr val="000000"/>
                 </a:solidFill>
@@ -8493,7 +8493,7 @@
               <a:buNone/>
             </a:pPr>
             <a:r>
-              <a:rPr lang="en-US" sz="1300" dirty="0">
+              <a:rPr lang="en-US" sz="1200" dirty="0">
                 <a:solidFill>
                   <a:srgbClr val="000000"/>
                 </a:solidFill>
@@ -8510,7 +8510,7 @@
               <a:buNone/>
             </a:pPr>
             <a:r>
-              <a:rPr lang="en-US" sz="1300" b="1" i="1" dirty="0">
+              <a:rPr lang="en-US" sz="1200" b="1" i="1" dirty="0">
                 <a:solidFill>
                   <a:srgbClr val="3E7EC7"/>
                 </a:solidFill>
@@ -8527,7 +8527,7 @@
               <a:buNone/>
             </a:pPr>
             <a:r>
-              <a:rPr lang="en-US" sz="1300" dirty="0">
+              <a:rPr lang="en-US" sz="1200" dirty="0">
                 <a:solidFill>
                   <a:srgbClr val="000000"/>
                 </a:solidFill>
@@ -8537,7 +8537,7 @@
               </a:rPr>
               <a:t> を加えたもの</a:t>
             </a:r>
-            <a:endParaRPr lang="en-US" sz="1600" dirty="0"/>
+            <a:endParaRPr lang="en-US" sz="1400" dirty="0"/>
           </a:p>
           <a:p>
             <a:pPr algn="l" indent="0" marL="0">
@@ -8547,7 +8547,7 @@
               <a:buNone/>
             </a:pPr>
             <a:r>
-              <a:rPr lang="en-US" sz="1300" dirty="0">
+              <a:rPr lang="en-US" sz="1200" dirty="0">
                 <a:solidFill>
                   <a:srgbClr val="000000"/>
                 </a:solidFill>
@@ -8557,7 +8557,7 @@
               </a:rPr>
               <a:t>  ◾ Hiding = 次の 3 つを </a:t>
             </a:r>
-            <a:endParaRPr lang="en-US" sz="1600" dirty="0"/>
+            <a:endParaRPr lang="en-US" sz="1400" dirty="0"/>
           </a:p>
           <a:p>
             <a:pPr algn="l" indent="0" marL="0">
@@ -8567,7 +8567,7 @@
               <a:buNone/>
             </a:pPr>
             <a:r>
-              <a:rPr lang="en-US" sz="1300" b="1" dirty="0">
+              <a:rPr lang="en-US" sz="1200" b="1" dirty="0">
                 <a:solidFill>
                   <a:srgbClr val="C0504D"/>
                 </a:solidFill>
@@ -8584,7 +8584,7 @@
               <a:buNone/>
             </a:pPr>
             <a:r>
-              <a:rPr lang="en-US" sz="1300" dirty="0">
+              <a:rPr lang="en-US" sz="1200" dirty="0">
                 <a:solidFill>
                   <a:srgbClr val="000000"/>
                 </a:solidFill>
@@ -8594,7 +8594,7 @@
               </a:rPr>
               <a:t> 明かさない:</a:t>
             </a:r>
-            <a:endParaRPr lang="en-US" sz="1600" dirty="0"/>
+            <a:endParaRPr lang="en-US" sz="1400" dirty="0"/>
           </a:p>
           <a:p>
             <a:pPr algn="l" indent="0" marL="0">
@@ -8604,7 +8604,7 @@
               <a:buNone/>
             </a:pPr>
             <a:r>
-              <a:rPr lang="en-US" sz="1300" dirty="0">
+              <a:rPr lang="en-US" sz="1200" dirty="0">
                 <a:solidFill>
                   <a:srgbClr val="000000"/>
                 </a:solidFill>
@@ -8614,7 +8614,7 @@
               </a:rPr>
               <a:t>        ① 中間状態 z_1, z_2, …, z_{i-1} （隠蔽）</a:t>
             </a:r>
-            <a:endParaRPr lang="en-US" sz="1600" dirty="0"/>
+            <a:endParaRPr lang="en-US" sz="1400" dirty="0"/>
           </a:p>
           <a:p>
             <a:pPr algn="l" indent="0" marL="0">
@@ -8624,7 +8624,7 @@
               <a:buNone/>
             </a:pPr>
             <a:r>
-              <a:rPr lang="en-US" sz="1300" dirty="0">
+              <a:rPr lang="en-US" sz="1200" dirty="0">
                 <a:solidFill>
                   <a:srgbClr val="000000"/>
                 </a:solidFill>
@@ -8634,7 +8634,7 @@
               </a:rPr>
               <a:t>        ② 各 step の witness ω_1, …, ω_i （秘匿）</a:t>
             </a:r>
-            <a:endParaRPr lang="en-US" sz="1600" dirty="0"/>
+            <a:endParaRPr lang="en-US" sz="1400" dirty="0"/>
           </a:p>
           <a:p>
             <a:pPr algn="l" indent="0" marL="0">
@@ -8644,7 +8644,7 @@
               <a:buNone/>
             </a:pPr>
             <a:r>
-              <a:rPr lang="en-US" sz="1300" dirty="0">
+              <a:rPr lang="en-US" sz="1200" dirty="0">
                 <a:solidFill>
                   <a:srgbClr val="000000"/>
                 </a:solidFill>
@@ -8654,7 +8654,7 @@
               </a:rPr>
               <a:t>        ③ 証明 π_i と witness のリンク性</a:t>
             </a:r>
-            <a:endParaRPr lang="en-US" sz="1600" dirty="0"/>
+            <a:endParaRPr lang="en-US" sz="1400" dirty="0"/>
           </a:p>
           <a:p>
             <a:pPr algn="l" indent="0" marL="0">
@@ -8664,7 +8664,7 @@
               <a:buNone/>
             </a:pPr>
             <a:r>
-              <a:rPr lang="en-US" sz="1600" dirty="0">
+              <a:rPr lang="en-US" sz="1400" dirty="0">
                 <a:solidFill>
                   <a:srgbClr val="000000"/>
                 </a:solidFill>
@@ -8682,7 +8682,7 @@
               <a:buNone/>
             </a:pPr>
             <a:r>
-              <a:rPr lang="en-US" sz="1300" b="1" dirty="0">
+              <a:rPr lang="en-US" sz="1200" b="1" dirty="0">
                 <a:solidFill>
                   <a:srgbClr val="000000"/>
                 </a:solidFill>
@@ -8692,7 +8692,7 @@
               </a:rPr>
               <a:t>  ◾ なぜ重要か（zkVM の文脈）</a:t>
             </a:r>
-            <a:endParaRPr lang="en-US" sz="1600" dirty="0"/>
+            <a:endParaRPr lang="en-US" sz="1400" dirty="0"/>
           </a:p>
           <a:p>
             <a:pPr algn="l" indent="0" marL="0">
@@ -8702,7 +8702,7 @@
               <a:buNone/>
             </a:pPr>
             <a:r>
-              <a:rPr lang="en-US" sz="1300" dirty="0">
+              <a:rPr lang="en-US" sz="1200" dirty="0">
                 <a:solidFill>
                   <a:srgbClr val="000000"/>
                 </a:solidFill>
@@ -8712,7 +8712,7 @@
               </a:rPr>
               <a:t>        LLM inference / 医療データ / 秘密鍵計算など</a:t>
             </a:r>
-            <a:endParaRPr lang="en-US" sz="1600" dirty="0"/>
+            <a:endParaRPr lang="en-US" sz="1400" dirty="0"/>
           </a:p>
           <a:p>
             <a:pPr algn="l" indent="0" marL="0">
@@ -8722,7 +8722,7 @@
               <a:buNone/>
             </a:pPr>
             <a:r>
-              <a:rPr lang="en-US" sz="1300" dirty="0">
+              <a:rPr lang="en-US" sz="1200" dirty="0">
                 <a:solidFill>
                   <a:srgbClr val="000000"/>
                 </a:solidFill>
@@ -8732,7 +8732,7 @@
               </a:rPr>
               <a:t>        中身を知られずに「正しく実行された」ことだけを示したい</a:t>
             </a:r>
-            <a:endParaRPr lang="en-US" sz="1600" dirty="0"/>
+            <a:endParaRPr lang="en-US" sz="1400" dirty="0"/>
           </a:p>
         </p:txBody>
       </p:sp>
@@ -8744,7 +8744,7 @@
         </p:nvSpPr>
         <p:spPr>
           <a:xfrm>
-            <a:off x="393192" y="3703320"/>
+            <a:off x="393192" y="3657600"/>
             <a:ext cx="8284464" cy="0"/>
           </a:xfrm>
           <a:prstGeom prst="line">
@@ -8767,8 +8767,8 @@
         </p:nvSpPr>
         <p:spPr>
           <a:xfrm>
-            <a:off x="393192" y="3886200"/>
-            <a:ext cx="8284464" cy="2560320"/>
+            <a:off x="393192" y="3794760"/>
+            <a:ext cx="8284464" cy="2468880"/>
           </a:xfrm>
           <a:prstGeom prst="rect">
             <a:avLst/>
@@ -8787,7 +8787,7 @@
               <a:buNone/>
             </a:pPr>
             <a:r>
-              <a:rPr lang="en-US" sz="1600" b="1" dirty="0">
+              <a:rPr lang="en-US" sz="1400" b="1" dirty="0">
                 <a:solidFill>
                   <a:srgbClr val="3E7EC7"/>
                 </a:solidFill>
@@ -8797,7 +8797,7 @@
               </a:rPr>
               <a:t>■  NovaBlindFold ── 追加 SNARK なしで ZK を加える技法</a:t>
             </a:r>
-            <a:endParaRPr lang="en-US" sz="1600" dirty="0"/>
+            <a:endParaRPr lang="en-US" sz="1400" dirty="0"/>
           </a:p>
           <a:p>
             <a:pPr algn="l" indent="0" marL="0">
@@ -8807,7 +8807,7 @@
               <a:buNone/>
             </a:pPr>
             <a:r>
-              <a:rPr lang="en-US" sz="1600" dirty="0">
+              <a:rPr lang="en-US" sz="1400" dirty="0">
                 <a:solidFill>
                   <a:srgbClr val="000000"/>
                 </a:solidFill>
@@ -8825,7 +8825,7 @@
               <a:buNone/>
             </a:pPr>
             <a:r>
-              <a:rPr lang="en-US" sz="1300" dirty="0">
+              <a:rPr lang="en-US" sz="1200" dirty="0">
                 <a:solidFill>
                   <a:srgbClr val="000000"/>
                 </a:solidFill>
@@ -8842,7 +8842,7 @@
               <a:buNone/>
             </a:pPr>
             <a:r>
-              <a:rPr lang="en-US" sz="1300" i="1" dirty="0">
+              <a:rPr lang="en-US" sz="1200" i="1" dirty="0">
                 <a:solidFill>
                   <a:srgbClr val="000000"/>
                 </a:solidFill>
@@ -8859,7 +8859,7 @@
               <a:buNone/>
             </a:pPr>
             <a:r>
-              <a:rPr lang="en-US" sz="1300" dirty="0">
+              <a:rPr lang="en-US" sz="1200" dirty="0">
                 <a:solidFill>
                   <a:srgbClr val="000000"/>
                 </a:solidFill>
@@ -8869,7 +8869,7 @@
               </a:rPr>
               <a:t> を利用する</a:t>
             </a:r>
-            <a:endParaRPr lang="en-US" sz="1600" dirty="0"/>
+            <a:endParaRPr lang="en-US" sz="1400" dirty="0"/>
           </a:p>
           <a:p>
             <a:pPr algn="l" indent="0" marL="0">
@@ -8879,7 +8879,7 @@
               <a:buNone/>
             </a:pPr>
             <a:r>
-              <a:rPr lang="en-US" sz="1300" dirty="0">
+              <a:rPr lang="en-US" sz="1200" dirty="0">
                 <a:solidFill>
                   <a:srgbClr val="000000"/>
                 </a:solidFill>
@@ -8896,7 +8896,7 @@
               <a:buNone/>
             </a:pPr>
             <a:r>
-              <a:rPr lang="en-US" sz="1300" i="1" dirty="0">
+              <a:rPr lang="en-US" sz="1200" i="1" dirty="0">
                 <a:solidFill>
                   <a:srgbClr val="000000"/>
                 </a:solidFill>
@@ -8913,7 +8913,7 @@
               <a:buNone/>
             </a:pPr>
             <a:r>
-              <a:rPr lang="en-US" sz="1300" dirty="0">
+              <a:rPr lang="en-US" sz="1200" dirty="0">
                 <a:solidFill>
                   <a:srgbClr val="000000"/>
                 </a:solidFill>
@@ -8923,7 +8923,7 @@
               </a:rPr>
               <a:t> を fold して IVC 証明に混ぜる:</a:t>
             </a:r>
-            <a:endParaRPr lang="en-US" sz="1600" dirty="0"/>
+            <a:endParaRPr lang="en-US" sz="1400" dirty="0"/>
           </a:p>
           <a:p>
             <a:pPr algn="l" indent="0" marL="0">
@@ -8933,7 +8933,7 @@
               <a:buNone/>
             </a:pPr>
             <a:r>
-              <a:rPr lang="en-US" sz="1600" dirty="0">
+              <a:rPr lang="en-US" sz="1400" dirty="0">
                 <a:solidFill>
                   <a:srgbClr val="000000"/>
                 </a:solidFill>
@@ -8950,7 +8950,7 @@
               <a:buNone/>
             </a:pPr>
             <a:r>
-              <a:rPr lang="en-US" sz="1400" b="1" i="1" dirty="0">
+              <a:rPr lang="en-US" sz="1300" b="1" i="1" dirty="0">
                 <a:solidFill>
                   <a:srgbClr val="3E7EC7"/>
                 </a:solidFill>
@@ -8967,7 +8967,7 @@
               <a:buNone/>
             </a:pPr>
             <a:r>
-              <a:rPr lang="en-US" sz="1400" dirty="0">
+              <a:rPr lang="en-US" sz="1300" dirty="0">
                 <a:solidFill>
                   <a:srgbClr val="000000"/>
                 </a:solidFill>
@@ -8984,7 +8984,7 @@
               <a:buNone/>
             </a:pPr>
             <a:r>
-              <a:rPr lang="en-US" sz="1400" i="1" dirty="0">
+              <a:rPr lang="en-US" sz="1300" i="1" dirty="0">
                 <a:solidFill>
                   <a:srgbClr val="000000"/>
                 </a:solidFill>
@@ -9001,7 +9001,7 @@
               <a:buNone/>
             </a:pPr>
             <a:r>
-              <a:rPr lang="en-US" sz="1400" dirty="0">
+              <a:rPr lang="en-US" sz="1300" dirty="0">
                 <a:solidFill>
                   <a:srgbClr val="000000"/>
                 </a:solidFill>
@@ -9018,7 +9018,7 @@
               <a:buNone/>
             </a:pPr>
             <a:r>
-              <a:rPr lang="en-US" sz="1400" i="1" dirty="0">
+              <a:rPr lang="en-US" sz="1300" i="1" dirty="0">
                 <a:solidFill>
                   <a:srgbClr val="000000"/>
                 </a:solidFill>
@@ -9035,7 +9035,7 @@
               <a:buNone/>
             </a:pPr>
             <a:r>
-              <a:rPr lang="en-US" sz="1400" dirty="0">
+              <a:rPr lang="en-US" sz="1300" dirty="0">
                 <a:solidFill>
                   <a:srgbClr val="000000"/>
                 </a:solidFill>
@@ -9045,7 +9045,7 @@
               </a:rPr>
               <a:t>)</a:t>
             </a:r>
-            <a:endParaRPr lang="en-US" sz="1600" dirty="0"/>
+            <a:endParaRPr lang="en-US" sz="1400" dirty="0"/>
           </a:p>
           <a:p>
             <a:pPr algn="l" indent="0" marL="0">
@@ -9055,7 +9055,7 @@
               <a:buNone/>
             </a:pPr>
             <a:r>
-              <a:rPr lang="en-US" sz="1300" dirty="0">
+              <a:rPr lang="en-US" sz="1200" dirty="0">
                 <a:solidFill>
                   <a:srgbClr val="000000"/>
                 </a:solidFill>
@@ -9065,7 +9065,7 @@
               </a:rPr>
               <a:t>  ◾ blinding 性の意味:</a:t>
             </a:r>
-            <a:endParaRPr lang="en-US" sz="1600" dirty="0"/>
+            <a:endParaRPr lang="en-US" sz="1400" dirty="0"/>
           </a:p>
           <a:p>
             <a:pPr algn="l" indent="0" marL="0">
@@ -9075,7 +9075,7 @@
               <a:buNone/>
             </a:pPr>
             <a:r>
-              <a:rPr lang="en-US" sz="1300" dirty="0">
+              <a:rPr lang="en-US" sz="1200" dirty="0">
                 <a:solidFill>
                   <a:srgbClr val="000000"/>
                 </a:solidFill>
@@ -9092,7 +9092,7 @@
               <a:buNone/>
             </a:pPr>
             <a:r>
-              <a:rPr lang="en-US" sz="1300" i="1" dirty="0">
+              <a:rPr lang="en-US" sz="1200" i="1" dirty="0">
                 <a:solidFill>
                   <a:srgbClr val="3E7EC7"/>
                 </a:solidFill>
@@ -9109,7 +9109,7 @@
               <a:buNone/>
             </a:pPr>
             <a:r>
-              <a:rPr lang="en-US" sz="1300" dirty="0">
+              <a:rPr lang="en-US" sz="1200" dirty="0">
                 <a:solidFill>
                   <a:srgbClr val="000000"/>
                 </a:solidFill>
@@ -9119,7 +9119,7 @@
               </a:rPr>
               <a:t> を満たす</a:t>
             </a:r>
-            <a:endParaRPr lang="en-US" sz="1600" dirty="0"/>
+            <a:endParaRPr lang="en-US" sz="1400" dirty="0"/>
           </a:p>
           <a:p>
             <a:pPr algn="l" indent="0" marL="0">
@@ -9129,7 +9129,7 @@
               <a:buNone/>
             </a:pPr>
             <a:r>
-              <a:rPr lang="en-US" sz="1600" dirty="0">
+              <a:rPr lang="en-US" sz="1400" dirty="0">
                 <a:solidFill>
                   <a:srgbClr val="000000"/>
                 </a:solidFill>
@@ -9147,7 +9147,7 @@
               <a:buNone/>
             </a:pPr>
             <a:r>
-              <a:rPr lang="en-US" sz="1300" b="1" dirty="0">
+              <a:rPr lang="en-US" sz="1200" b="1" dirty="0">
                 <a:solidFill>
                   <a:srgbClr val="000000"/>
                 </a:solidFill>
@@ -9157,7 +9157,7 @@
               </a:rPr>
               <a:t>  ◾ 既存方式との比較:</a:t>
             </a:r>
-            <a:endParaRPr lang="en-US" sz="1600" dirty="0"/>
+            <a:endParaRPr lang="en-US" sz="1400" dirty="0"/>
           </a:p>
           <a:p>
             <a:pPr algn="l" indent="0" marL="0">
@@ -9167,7 +9167,7 @@
               <a:buNone/>
             </a:pPr>
             <a:r>
-              <a:rPr lang="en-US" sz="1600" dirty="0">
+              <a:rPr lang="en-US" sz="1400" dirty="0">
                 <a:solidFill>
                   <a:srgbClr val="000000"/>
                 </a:solidFill>
@@ -9184,7 +9184,7 @@
               <a:buNone/>
             </a:pPr>
             <a:r>
-              <a:rPr lang="en-US" sz="1300" dirty="0">
+              <a:rPr lang="en-US" sz="1200" dirty="0">
                 <a:solidFill>
                   <a:srgbClr val="000000"/>
                 </a:solidFill>
@@ -9201,7 +9201,7 @@
               <a:buNone/>
             </a:pPr>
             <a:r>
-              <a:rPr lang="en-US" sz="1300" dirty="0">
+              <a:rPr lang="en-US" sz="1200" dirty="0">
                 <a:solidFill>
                   <a:srgbClr val="C0504D"/>
                 </a:solidFill>
@@ -9211,7 +9211,7 @@
               </a:rPr>
               <a:t> ── 別 SNARK（Groth16 等）を被せて ZK 化</a:t>
             </a:r>
-            <a:endParaRPr lang="en-US" sz="1600" dirty="0"/>
+            <a:endParaRPr lang="en-US" sz="1400" dirty="0"/>
           </a:p>
           <a:p>
             <a:pPr algn="l" indent="0" marL="0">
@@ -9221,7 +9221,7 @@
               <a:buNone/>
             </a:pPr>
             <a:r>
-              <a:rPr lang="en-US" sz="1600" dirty="0">
+              <a:rPr lang="en-US" sz="1400" dirty="0">
                 <a:solidFill>
                   <a:srgbClr val="000000"/>
                 </a:solidFill>
@@ -9238,7 +9238,7 @@
               <a:buNone/>
             </a:pPr>
             <a:r>
-              <a:rPr lang="en-US" sz="1300" b="1" dirty="0">
+              <a:rPr lang="en-US" sz="1200" b="1" dirty="0">
                 <a:solidFill>
                   <a:srgbClr val="000000"/>
                 </a:solidFill>
@@ -9255,7 +9255,7 @@
               <a:buNone/>
             </a:pPr>
             <a:r>
-              <a:rPr lang="en-US" sz="1300" b="1" dirty="0">
+              <a:rPr lang="en-US" sz="1200" b="1" dirty="0">
                 <a:solidFill>
                   <a:srgbClr val="3E7EC7"/>
                 </a:solidFill>
@@ -9265,7 +9265,7 @@
               </a:rPr>
               <a:t> ── 上の Fold(π, ρ) だけで ZK 化（回路サイズ小）</a:t>
             </a:r>
-            <a:endParaRPr lang="en-US" sz="1600" dirty="0"/>
+            <a:endParaRPr lang="en-US" sz="1400" dirty="0"/>
           </a:p>
         </p:txBody>
       </p:sp>
@@ -12639,7 +12639,7 @@
               <a:buNone/>
             </a:pPr>
             <a:r>
-              <a:rPr lang="en-US" sz="1300" dirty="0">
+              <a:rPr lang="en-US" sz="1200" dirty="0">
                 <a:solidFill>
                   <a:srgbClr val="282629"/>
                 </a:solidFill>
@@ -12647,16 +12647,16 @@
                 <a:ea typeface="Yu Gothic" pitchFamily="34" charset="-122"/>
                 <a:cs typeface="Yu Gothic" pitchFamily="34" charset="-120"/>
               </a:rPr>
-              <a:t>証明したい命題 x と，証明者だけが知っている証拠 ω（witness）に対し，</a:t>
-            </a:r>
-            <a:endParaRPr lang="en-US" sz="1300" dirty="0"/>
-          </a:p>
-          <a:p>
-            <a:pPr algn="l" indent="0" marL="0">
-              <a:buNone/>
-            </a:pPr>
-            <a:r>
-              <a:rPr lang="en-US" sz="1300" dirty="0">
+              <a:t>証明したい命題 x と，証明者だけが知っている証拠 ω に対し，</a:t>
+            </a:r>
+            <a:endParaRPr lang="en-US" sz="1200" dirty="0"/>
+          </a:p>
+          <a:p>
+            <a:pPr algn="l" indent="0" marL="0">
+              <a:buNone/>
+            </a:pPr>
+            <a:r>
+              <a:rPr lang="en-US" sz="1200" dirty="0">
                 <a:solidFill>
                   <a:srgbClr val="282629"/>
                 </a:solidFill>
@@ -12664,22 +12664,22 @@
                 <a:ea typeface="Yu Gothic" pitchFamily="34" charset="-122"/>
                 <a:cs typeface="Yu Gothic" pitchFamily="34" charset="-120"/>
               </a:rPr>
-              <a:t>Verify(vk, x, π) → {0,1} によって誰でも検証できる小さな証明 π を生成する暗号プロトコル。</a:t>
-            </a:r>
-            <a:endParaRPr lang="en-US" sz="1300" dirty="0"/>
-          </a:p>
-          <a:p>
-            <a:pPr algn="l" indent="0" marL="0">
-              <a:buNone/>
-            </a:pPr>
-            <a:endParaRPr lang="en-US" sz="1300" dirty="0"/>
-          </a:p>
-          <a:p>
-            <a:pPr algn="l" indent="0" marL="0">
-              <a:buNone/>
-            </a:pPr>
-            <a:r>
-              <a:rPr lang="en-US" sz="1300" dirty="0">
+              <a:t>Verify(vk, x, π) → {0,1} で誰でも検証できる小さな証明 π を生成するプロトコル。</a:t>
+            </a:r>
+            <a:endParaRPr lang="en-US" sz="1200" dirty="0"/>
+          </a:p>
+          <a:p>
+            <a:pPr algn="l" indent="0" marL="0">
+              <a:buNone/>
+            </a:pPr>
+            <a:endParaRPr lang="en-US" sz="1200" dirty="0"/>
+          </a:p>
+          <a:p>
+            <a:pPr algn="l" indent="0" marL="0">
+              <a:buNone/>
+            </a:pPr>
+            <a:r>
+              <a:rPr lang="en-US" sz="1200" dirty="0">
                 <a:solidFill>
                   <a:srgbClr val="282629"/>
                 </a:solidFill>
@@ -12689,14 +12689,14 @@
               </a:rPr>
               <a:t>■ 満たすべき 3 性質</a:t>
             </a:r>
-            <a:endParaRPr lang="en-US" sz="1300" dirty="0"/>
-          </a:p>
-          <a:p>
-            <a:pPr algn="l" indent="0" marL="0">
-              <a:buNone/>
-            </a:pPr>
-            <a:r>
-              <a:rPr lang="en-US" sz="1300" dirty="0">
+            <a:endParaRPr lang="en-US" sz="1200" dirty="0"/>
+          </a:p>
+          <a:p>
+            <a:pPr algn="l" indent="0" marL="0">
+              <a:buNone/>
+            </a:pPr>
+            <a:r>
+              <a:rPr lang="en-US" sz="1200" dirty="0">
                 <a:solidFill>
                   <a:srgbClr val="282629"/>
                 </a:solidFill>
@@ -12704,16 +12704,16 @@
                 <a:ea typeface="Yu Gothic" pitchFamily="34" charset="-122"/>
                 <a:cs typeface="Yu Gothic" pitchFamily="34" charset="-120"/>
               </a:rPr>
-              <a:t>  ・ Completeness（完全性）── 真の命題は真と証明される</a:t>
-            </a:r>
-            <a:endParaRPr lang="en-US" sz="1300" dirty="0"/>
-          </a:p>
-          <a:p>
-            <a:pPr algn="l" indent="0" marL="0">
-              <a:buNone/>
-            </a:pPr>
-            <a:r>
-              <a:rPr lang="en-US" sz="1300" dirty="0">
+              <a:t>  ・ Completeness ── 真の命題は真と証明される</a:t>
+            </a:r>
+            <a:endParaRPr lang="en-US" sz="1200" dirty="0"/>
+          </a:p>
+          <a:p>
+            <a:pPr algn="l" indent="0" marL="0">
+              <a:buNone/>
+            </a:pPr>
+            <a:r>
+              <a:rPr lang="en-US" sz="1200" dirty="0">
                 <a:solidFill>
                   <a:srgbClr val="282629"/>
                 </a:solidFill>
@@ -12721,16 +12721,16 @@
                 <a:ea typeface="Yu Gothic" pitchFamily="34" charset="-122"/>
                 <a:cs typeface="Yu Gothic" pitchFamily="34" charset="-120"/>
               </a:rPr>
-              <a:t>  ・ Soundness（健全性）── 偽の命題は偽と判定される</a:t>
-            </a:r>
-            <a:endParaRPr lang="en-US" sz="1300" dirty="0"/>
-          </a:p>
-          <a:p>
-            <a:pPr algn="l" indent="0" marL="0">
-              <a:buNone/>
-            </a:pPr>
-            <a:r>
-              <a:rPr lang="en-US" sz="1300" dirty="0">
+              <a:t>  ・ Soundness ── 偽の命題は偽と判定される</a:t>
+            </a:r>
+            <a:endParaRPr lang="en-US" sz="1200" dirty="0"/>
+          </a:p>
+          <a:p>
+            <a:pPr algn="l" indent="0" marL="0">
+              <a:buNone/>
+            </a:pPr>
+            <a:r>
+              <a:rPr lang="en-US" sz="1200" dirty="0">
                 <a:solidFill>
                   <a:srgbClr val="282629"/>
                 </a:solidFill>
@@ -12738,22 +12738,22 @@
                 <a:ea typeface="Yu Gothic" pitchFamily="34" charset="-122"/>
                 <a:cs typeface="Yu Gothic" pitchFamily="34" charset="-120"/>
               </a:rPr>
-              <a:t>  ・ Zero-Knowledge（ゼロ知識性）── 命題の真偽以外は何も漏れない</a:t>
-            </a:r>
-            <a:endParaRPr lang="en-US" sz="1300" dirty="0"/>
-          </a:p>
-          <a:p>
-            <a:pPr algn="l" indent="0" marL="0">
-              <a:buNone/>
-            </a:pPr>
-            <a:endParaRPr lang="en-US" sz="1300" dirty="0"/>
-          </a:p>
-          <a:p>
-            <a:pPr algn="l" indent="0" marL="0">
-              <a:buNone/>
-            </a:pPr>
-            <a:r>
-              <a:rPr lang="en-US" sz="1300" dirty="0">
+              <a:t>  ・ Zero-Knowledge ── 命題の真偽以外は何も漏れない</a:t>
+            </a:r>
+            <a:endParaRPr lang="en-US" sz="1200" dirty="0"/>
+          </a:p>
+          <a:p>
+            <a:pPr algn="l" indent="0" marL="0">
+              <a:buNone/>
+            </a:pPr>
+            <a:endParaRPr lang="en-US" sz="1200" dirty="0"/>
+          </a:p>
+          <a:p>
+            <a:pPr algn="l" indent="0" marL="0">
+              <a:buNone/>
+            </a:pPr>
+            <a:r>
+              <a:rPr lang="en-US" sz="1200" dirty="0">
                 <a:solidFill>
                   <a:srgbClr val="282629"/>
                 </a:solidFill>
@@ -12763,14 +12763,14 @@
               </a:rPr>
               <a:t>■ 主な既存 SNARK</a:t>
             </a:r>
-            <a:endParaRPr lang="en-US" sz="1300" dirty="0"/>
-          </a:p>
-          <a:p>
-            <a:pPr algn="l" indent="0" marL="0">
-              <a:buNone/>
-            </a:pPr>
-            <a:r>
-              <a:rPr lang="en-US" sz="1300" dirty="0">
+            <a:endParaRPr lang="en-US" sz="1200" dirty="0"/>
+          </a:p>
+          <a:p>
+            <a:pPr algn="l" indent="0" marL="0">
+              <a:buNone/>
+            </a:pPr>
+            <a:r>
+              <a:rPr lang="en-US" sz="1200" dirty="0">
                 <a:solidFill>
                   <a:srgbClr val="282629"/>
                 </a:solidFill>
@@ -12778,16 +12778,16 @@
                 <a:ea typeface="Yu Gothic" pitchFamily="34" charset="-122"/>
                 <a:cs typeface="Yu Gothic" pitchFamily="34" charset="-120"/>
               </a:rPr>
-              <a:t>  ・ Groth16 ── 証明サイズ最小，trusted setup が必要</a:t>
-            </a:r>
-            <a:endParaRPr lang="en-US" sz="1300" dirty="0"/>
-          </a:p>
-          <a:p>
-            <a:pPr algn="l" indent="0" marL="0">
-              <a:buNone/>
-            </a:pPr>
-            <a:r>
-              <a:rPr lang="en-US" sz="1300" dirty="0">
+              <a:t>  ・ Groth16 ── 証明サイズ最小，trusted setup</a:t>
+            </a:r>
+            <a:endParaRPr lang="en-US" sz="1200" dirty="0"/>
+          </a:p>
+          <a:p>
+            <a:pPr algn="l" indent="0" marL="0">
+              <a:buNone/>
+            </a:pPr>
+            <a:r>
+              <a:rPr lang="en-US" sz="1200" dirty="0">
                 <a:solidFill>
                   <a:srgbClr val="282629"/>
                 </a:solidFill>
@@ -12797,14 +12797,14 @@
               </a:rPr>
               <a:t>  ・ PLONK ── universal setup，Plonkish arithmetization</a:t>
             </a:r>
-            <a:endParaRPr lang="en-US" sz="1300" dirty="0"/>
-          </a:p>
-          <a:p>
-            <a:pPr algn="l" indent="0" marL="0">
-              <a:buNone/>
-            </a:pPr>
-            <a:r>
-              <a:rPr lang="en-US" sz="1300" dirty="0">
+            <a:endParaRPr lang="en-US" sz="1200" dirty="0"/>
+          </a:p>
+          <a:p>
+            <a:pPr algn="l" indent="0" marL="0">
+              <a:buNone/>
+            </a:pPr>
+            <a:r>
+              <a:rPr lang="en-US" sz="1200" dirty="0">
                 <a:solidFill>
                   <a:srgbClr val="282629"/>
                 </a:solidFill>
@@ -12812,22 +12812,22 @@
                 <a:ea typeface="Yu Gothic" pitchFamily="34" charset="-122"/>
                 <a:cs typeface="Yu Gothic" pitchFamily="34" charset="-120"/>
               </a:rPr>
-              <a:t>  ・ STARK ── trusted setup 不要，post-quantum 安全性</a:t>
-            </a:r>
-            <a:endParaRPr lang="en-US" sz="1300" dirty="0"/>
-          </a:p>
-          <a:p>
-            <a:pPr algn="l" indent="0" marL="0">
-              <a:buNone/>
-            </a:pPr>
-            <a:endParaRPr lang="en-US" sz="1300" dirty="0"/>
-          </a:p>
-          <a:p>
-            <a:pPr algn="l" indent="0" marL="0">
-              <a:buNone/>
-            </a:pPr>
-            <a:r>
-              <a:rPr lang="en-US" sz="1300" dirty="0">
+              <a:t>  ・ STARK ── trusted setup 不要，post-quantum 安全</a:t>
+            </a:r>
+            <a:endParaRPr lang="en-US" sz="1200" dirty="0"/>
+          </a:p>
+          <a:p>
+            <a:pPr algn="l" indent="0" marL="0">
+              <a:buNone/>
+            </a:pPr>
+            <a:endParaRPr lang="en-US" sz="1200" dirty="0"/>
+          </a:p>
+          <a:p>
+            <a:pPr algn="l" indent="0" marL="0">
+              <a:buNone/>
+            </a:pPr>
+            <a:r>
+              <a:rPr lang="en-US" sz="1200" dirty="0">
                 <a:solidFill>
                   <a:srgbClr val="282629"/>
                 </a:solidFill>
@@ -12835,9 +12835,9 @@
                 <a:ea typeface="Yu Gothic" pitchFamily="34" charset="-122"/>
                 <a:cs typeface="Yu Gothic" pitchFamily="34" charset="-120"/>
               </a:rPr>
-              <a:t>■ HyperNova は SNARK そのものではなく「SNARK の合成法」を提案する論文。</a:t>
-            </a:r>
-            <a:endParaRPr lang="en-US" sz="1300" dirty="0"/>
+              <a:t>※ HyperNova は SNARK そのものではなく「SNARK の合成法」を提案する論文。</a:t>
+            </a:r>
+            <a:endParaRPr lang="en-US" sz="1200" dirty="0"/>
           </a:p>
         </p:txBody>
       </p:sp>
@@ -16051,7 +16051,7 @@
               <a:buNone/>
             </a:pPr>
             <a:r>
-              <a:rPr lang="en-US" sz="1300" dirty="0">
+              <a:rPr lang="en-US" sz="1200" dirty="0">
                 <a:solidFill>
                   <a:srgbClr val="282629"/>
                 </a:solidFill>
@@ -16061,14 +16061,14 @@
               </a:rPr>
               <a:t>■ アイデア</a:t>
             </a:r>
-            <a:endParaRPr lang="en-US" sz="1300" dirty="0"/>
-          </a:p>
-          <a:p>
-            <a:pPr algn="l" indent="0" marL="0">
-              <a:buNone/>
-            </a:pPr>
-            <a:r>
-              <a:rPr lang="en-US" sz="1300" dirty="0">
+            <a:endParaRPr lang="en-US" sz="1200" dirty="0"/>
+          </a:p>
+          <a:p>
+            <a:pPr algn="l" indent="0" marL="0">
+              <a:buNone/>
+            </a:pPr>
+            <a:r>
+              <a:rPr lang="en-US" sz="1200" dirty="0">
                 <a:solidFill>
                   <a:srgbClr val="282629"/>
                 </a:solidFill>
@@ -16076,16 +16076,16 @@
                 <a:ea typeface="Yu Gothic" pitchFamily="34" charset="-122"/>
                 <a:cs typeface="Yu Gothic" pitchFamily="34" charset="-120"/>
               </a:rPr>
-              <a:t>  ・ NP 関係 R の instance 2 つ (u₁, u₂) を，新しい instance u が満たす式に reduce</a:t>
-            </a:r>
-            <a:endParaRPr lang="en-US" sz="1300" dirty="0"/>
-          </a:p>
-          <a:p>
-            <a:pPr algn="l" indent="0" marL="0">
-              <a:buNone/>
-            </a:pPr>
-            <a:r>
-              <a:rPr lang="en-US" sz="1300" dirty="0">
+              <a:t>  ・ NP 関係 R の instance 2 つ (u₁, u₂) を新しい instance u に reduce</a:t>
+            </a:r>
+            <a:endParaRPr lang="en-US" sz="1200" dirty="0"/>
+          </a:p>
+          <a:p>
+            <a:pPr algn="l" indent="0" marL="0">
+              <a:buNone/>
+            </a:pPr>
+            <a:r>
+              <a:rPr lang="en-US" sz="1200" dirty="0">
                 <a:solidFill>
                   <a:srgbClr val="282629"/>
                 </a:solidFill>
@@ -16095,14 +16095,14 @@
               </a:rPr>
               <a:t>  ・ u₁ が真 ⟺ u₂ が真 ⟺ u が真 ── 等価性を保つ</a:t>
             </a:r>
-            <a:endParaRPr lang="en-US" sz="1300" dirty="0"/>
-          </a:p>
-          <a:p>
-            <a:pPr algn="l" indent="0" marL="0">
-              <a:buNone/>
-            </a:pPr>
-            <a:r>
-              <a:rPr lang="en-US" sz="1300" dirty="0">
+            <a:endParaRPr lang="en-US" sz="1200" dirty="0"/>
+          </a:p>
+          <a:p>
+            <a:pPr algn="l" indent="0" marL="0">
+              <a:buNone/>
+            </a:pPr>
+            <a:r>
+              <a:rPr lang="en-US" sz="1200" dirty="0">
                 <a:solidFill>
                   <a:srgbClr val="282629"/>
                 </a:solidFill>
@@ -16112,20 +16112,20 @@
               </a:rPr>
               <a:t>  ・ 並列で複数の証明を 1 つに集約できる</a:t>
             </a:r>
-            <a:endParaRPr lang="en-US" sz="1300" dirty="0"/>
-          </a:p>
-          <a:p>
-            <a:pPr algn="l" indent="0" marL="0">
-              <a:buNone/>
-            </a:pPr>
-            <a:endParaRPr lang="en-US" sz="1300" dirty="0"/>
-          </a:p>
-          <a:p>
-            <a:pPr algn="l" indent="0" marL="0">
-              <a:buNone/>
-            </a:pPr>
-            <a:r>
-              <a:rPr lang="en-US" sz="1300" dirty="0">
+            <a:endParaRPr lang="en-US" sz="1200" dirty="0"/>
+          </a:p>
+          <a:p>
+            <a:pPr algn="l" indent="0" marL="0">
+              <a:buNone/>
+            </a:pPr>
+            <a:endParaRPr lang="en-US" sz="1200" dirty="0"/>
+          </a:p>
+          <a:p>
+            <a:pPr algn="l" indent="0" marL="0">
+              <a:buNone/>
+            </a:pPr>
+            <a:r>
+              <a:rPr lang="en-US" sz="1200" dirty="0">
                 <a:solidFill>
                   <a:srgbClr val="282629"/>
                 </a:solidFill>
@@ -16135,14 +16135,14 @@
               </a:rPr>
               <a:t>■ Nova（CRYPTO 2022）</a:t>
             </a:r>
-            <a:endParaRPr lang="en-US" sz="1300" dirty="0"/>
-          </a:p>
-          <a:p>
-            <a:pPr algn="l" indent="0" marL="0">
-              <a:buNone/>
-            </a:pPr>
-            <a:r>
-              <a:rPr lang="en-US" sz="1300" dirty="0">
+            <a:endParaRPr lang="en-US" sz="1200" dirty="0"/>
+          </a:p>
+          <a:p>
+            <a:pPr algn="l" indent="0" marL="0">
+              <a:buNone/>
+            </a:pPr>
+            <a:r>
+              <a:rPr lang="en-US" sz="1200" dirty="0">
                 <a:solidFill>
                   <a:srgbClr val="282629"/>
                 </a:solidFill>
@@ -16152,14 +16152,14 @@
               </a:rPr>
               <a:t>  ・ folding scheme を SNARK の再帰に使う初の構成</a:t>
             </a:r>
-            <a:endParaRPr lang="en-US" sz="1300" dirty="0"/>
-          </a:p>
-          <a:p>
-            <a:pPr algn="l" indent="0" marL="0">
-              <a:buNone/>
-            </a:pPr>
-            <a:r>
-              <a:rPr lang="en-US" sz="1300" dirty="0">
+            <a:endParaRPr lang="en-US" sz="1200" dirty="0"/>
+          </a:p>
+          <a:p>
+            <a:pPr algn="l" indent="0" marL="0">
+              <a:buNone/>
+            </a:pPr>
+            <a:r>
+              <a:rPr lang="en-US" sz="1200" dirty="0">
                 <a:solidFill>
                   <a:srgbClr val="282629"/>
                 </a:solidFill>
@@ -16167,16 +16167,16 @@
                 <a:ea typeface="Yu Gothic" pitchFamily="34" charset="-122"/>
                 <a:cs typeface="Yu Gothic" pitchFamily="34" charset="-120"/>
               </a:rPr>
-              <a:t>  ・ 双子楕円曲線（Pallas / Vesta など）のサイクル上で動作</a:t>
-            </a:r>
-            <a:endParaRPr lang="en-US" sz="1300" dirty="0"/>
-          </a:p>
-          <a:p>
-            <a:pPr algn="l" indent="0" marL="0">
-              <a:buNone/>
-            </a:pPr>
-            <a:r>
-              <a:rPr lang="en-US" sz="1300" dirty="0">
+              <a:t>  ・ 双子楕円曲線（Pallas / Vesta）サイクル上で動作</a:t>
+            </a:r>
+            <a:endParaRPr lang="en-US" sz="1200" dirty="0"/>
+          </a:p>
+          <a:p>
+            <a:pPr algn="l" indent="0" marL="0">
+              <a:buNone/>
+            </a:pPr>
+            <a:r>
+              <a:rPr lang="en-US" sz="1200" dirty="0">
                 <a:solidFill>
                   <a:srgbClr val="282629"/>
                 </a:solidFill>
@@ -16184,22 +16184,22 @@
                 <a:ea typeface="Yu Gothic" pitchFamily="34" charset="-122"/>
                 <a:cs typeface="Yu Gothic" pitchFamily="34" charset="-120"/>
               </a:rPr>
-              <a:t>  ・ R1CS 専用 ── 他の制約システムではそのまま使えない</a:t>
-            </a:r>
-            <a:endParaRPr lang="en-US" sz="1300" dirty="0"/>
-          </a:p>
-          <a:p>
-            <a:pPr algn="l" indent="0" marL="0">
-              <a:buNone/>
-            </a:pPr>
-            <a:endParaRPr lang="en-US" sz="1300" dirty="0"/>
-          </a:p>
-          <a:p>
-            <a:pPr algn="l" indent="0" marL="0">
-              <a:buNone/>
-            </a:pPr>
-            <a:r>
-              <a:rPr lang="en-US" sz="1300" dirty="0">
+              <a:t>  ・ R1CS 専用 ── 他システムではそのまま使えない</a:t>
+            </a:r>
+            <a:endParaRPr lang="en-US" sz="1200" dirty="0"/>
+          </a:p>
+          <a:p>
+            <a:pPr algn="l" indent="0" marL="0">
+              <a:buNone/>
+            </a:pPr>
+            <a:endParaRPr lang="en-US" sz="1200" dirty="0"/>
+          </a:p>
+          <a:p>
+            <a:pPr algn="l" indent="0" marL="0">
+              <a:buNone/>
+            </a:pPr>
+            <a:r>
+              <a:rPr lang="en-US" sz="1200" dirty="0">
                 <a:solidFill>
                   <a:srgbClr val="282629"/>
                 </a:solidFill>
@@ -16209,14 +16209,14 @@
               </a:rPr>
               <a:t>■ Nova の制約</a:t>
             </a:r>
-            <a:endParaRPr lang="en-US" sz="1300" dirty="0"/>
-          </a:p>
-          <a:p>
-            <a:pPr algn="l" indent="0" marL="0">
-              <a:buNone/>
-            </a:pPr>
-            <a:r>
-              <a:rPr lang="en-US" sz="1300" dirty="0">
+            <a:endParaRPr lang="en-US" sz="1200" dirty="0"/>
+          </a:p>
+          <a:p>
+            <a:pPr algn="l" indent="0" marL="0">
+              <a:buNone/>
+            </a:pPr>
+            <a:r>
+              <a:rPr lang="en-US" sz="1200" dirty="0">
                 <a:solidFill>
                   <a:srgbClr val="282629"/>
                 </a:solidFill>
@@ -16224,16 +16224,16 @@
                 <a:ea typeface="Yu Gothic" pitchFamily="34" charset="-122"/>
                 <a:cs typeface="Yu Gothic" pitchFamily="34" charset="-120"/>
               </a:rPr>
-              <a:t>  ・ prover のコストが「ステップ回路サイズ |C|」に比例してしまう</a:t>
-            </a:r>
-            <a:endParaRPr lang="en-US" sz="1300" dirty="0"/>
-          </a:p>
-          <a:p>
-            <a:pPr algn="l" indent="0" marL="0">
-              <a:buNone/>
-            </a:pPr>
-            <a:r>
-              <a:rPr lang="en-US" sz="1300" dirty="0">
+              <a:t>  ・ prover のコストが「ステップ回路サイズ |C|」に比例</a:t>
+            </a:r>
+            <a:endParaRPr lang="en-US" sz="1200" dirty="0"/>
+          </a:p>
+          <a:p>
+            <a:pPr algn="l" indent="0" marL="0">
+              <a:buNone/>
+            </a:pPr>
+            <a:r>
+              <a:rPr lang="en-US" sz="1200" dirty="0">
                 <a:solidFill>
                   <a:srgbClr val="282629"/>
                 </a:solidFill>
@@ -16243,14 +16243,14 @@
               </a:rPr>
               <a:t>  ・ Plonkish / AIR 上で同じ folding をすると効率が大きく落ちる</a:t>
             </a:r>
-            <a:endParaRPr lang="en-US" sz="1300" dirty="0"/>
-          </a:p>
-          <a:p>
-            <a:pPr algn="l" indent="0" marL="0">
-              <a:buNone/>
-            </a:pPr>
-            <a:r>
-              <a:rPr lang="en-US" sz="1300" dirty="0">
+            <a:endParaRPr lang="en-US" sz="1200" dirty="0"/>
+          </a:p>
+          <a:p>
+            <a:pPr algn="l" indent="0" marL="0">
+              <a:buNone/>
+            </a:pPr>
+            <a:r>
+              <a:rPr lang="en-US" sz="1200" dirty="0">
                 <a:solidFill>
                   <a:srgbClr val="282629"/>
                 </a:solidFill>
@@ -16258,9 +16258,9 @@
                 <a:ea typeface="Yu Gothic" pitchFamily="34" charset="-122"/>
                 <a:cs typeface="Yu Gothic" pitchFamily="34" charset="-120"/>
               </a:rPr>
-              <a:t>  ・ R1CS に閉じているため，各 SNARK 系で個別に最適化が必要だった</a:t>
-            </a:r>
-            <a:endParaRPr lang="en-US" sz="1300" dirty="0"/>
+              <a:t>  ・ R1CS に閉じているため，他 SNARK 系で個別最適化が必要</a:t>
+            </a:r>
+            <a:endParaRPr lang="en-US" sz="1200" dirty="0"/>
           </a:p>
         </p:txBody>
       </p:sp>
@@ -16575,7 +16575,7 @@
                 <a:ea typeface="Yu Gothic" pitchFamily="34" charset="-122"/>
                 <a:cs typeface="Yu Gothic" pitchFamily="34" charset="-120"/>
               </a:rPr>
-              <a:t>  ・ 各ステップの回路を表現する「constraint system」の形に依存しない</a:t>
+              <a:t>  ・ constraint system の形に依存しない</a:t>
             </a:r>
             <a:endParaRPr lang="en-US" sz="1200" dirty="0"/>
           </a:p>
@@ -16632,7 +16632,7 @@
                 <a:ea typeface="Yu Gothic" pitchFamily="34" charset="-122"/>
                 <a:cs typeface="Yu Gothic" pitchFamily="34" charset="-120"/>
               </a:rPr>
-              <a:t>  ・ Prover cost が「回路内の変数数 N」の 1 回の MSM で完了</a:t>
+              <a:t>  ・ Prover cost =「変数数 N の 1 回の MSM」で完了</a:t>
             </a:r>
             <a:endParaRPr lang="en-US" sz="1200" dirty="0"/>
           </a:p>
@@ -16649,7 +16649,7 @@
                 <a:ea typeface="Yu Gothic" pitchFamily="34" charset="-122"/>
                 <a:cs typeface="Yu Gothic" pitchFamily="34" charset="-120"/>
               </a:rPr>
-              <a:t>  ・─ Nova は各ステップで回路全体 |C| に比例した prover が必要だった</a:t>
+              <a:t>  ・─ Nova は各ステップで回路全体 |C| に比例した prover が必要</a:t>
             </a:r>
             <a:endParaRPr lang="en-US" sz="1200" dirty="0"/>
           </a:p>
@@ -16666,7 +16666,7 @@
                 <a:ea typeface="Yu Gothic" pitchFamily="34" charset="-122"/>
                 <a:cs typeface="Yu Gothic" pitchFamily="34" charset="-120"/>
               </a:rPr>
-              <a:t>  ・─ HyperNova は「呼ばれた命令の回路サイズ」に比例する à la carte コスト</a:t>
+              <a:t>  ・─ HyperNova は「呼ばれた命令の回路サイズ」に比例する à la carte</a:t>
             </a:r>
             <a:endParaRPr lang="en-US" sz="1200" dirty="0"/>
           </a:p>
@@ -16706,7 +16706,7 @@
                 <a:ea typeface="Yu Gothic" pitchFamily="34" charset="-122"/>
                 <a:cs typeface="Yu Gothic" pitchFamily="34" charset="-120"/>
               </a:rPr>
-              <a:t>■ 同時に提供される副次的な貢献</a:t>
+              <a:t>■ 同時に提供される副次的貢献</a:t>
             </a:r>
             <a:endParaRPr lang="en-US" sz="1200" dirty="0"/>
           </a:p>
@@ -16723,7 +16723,7 @@
                 <a:ea typeface="Yu Gothic" pitchFamily="34" charset="-122"/>
                 <a:cs typeface="Yu Gothic" pitchFamily="34" charset="-120"/>
               </a:rPr>
-              <a:t>  ・ Multi-folding（異なる NP relation 同士の fold）</a:t>
+              <a:t>  ・ Multi-folding ── 異なる NP relation 同士の fold</a:t>
             </a:r>
             <a:endParaRPr lang="en-US" sz="1200" dirty="0"/>
           </a:p>
@@ -16740,7 +16740,7 @@
                 <a:ea typeface="Yu Gothic" pitchFamily="34" charset="-122"/>
                 <a:cs typeface="Yu Gothic" pitchFamily="34" charset="-120"/>
               </a:rPr>
-              <a:t>  ・ CycleFold（双子楕円曲線サイクルの汎用化）</a:t>
+              <a:t>  ・ CycleFold ── 双子楕円曲線サイクルの汎用化</a:t>
             </a:r>
             <a:endParaRPr lang="en-US" sz="1200" dirty="0"/>
           </a:p>
@@ -16757,7 +16757,7 @@
                 <a:ea typeface="Yu Gothic" pitchFamily="34" charset="-122"/>
                 <a:cs typeface="Yu Gothic" pitchFamily="34" charset="-120"/>
               </a:rPr>
-              <a:t>  ・ NovaBlindFold（追加 SNARK なしで ZK を加える技法）</a:t>
+              <a:t>  ・ NovaBlindFold ── 追加 SNARK なしで ZK を加える技法</a:t>
             </a:r>
             <a:endParaRPr lang="en-US" sz="1200" dirty="0"/>
           </a:p>
@@ -16982,7 +16982,7 @@
               <a:buNone/>
             </a:pPr>
             <a:r>
-              <a:rPr lang="en-US" sz="1600" b="1" dirty="0">
+              <a:rPr lang="en-US" sz="1500" b="1" dirty="0">
                 <a:solidFill>
                   <a:srgbClr val="3E7EC7"/>
                 </a:solidFill>
@@ -16992,7 +16992,7 @@
               </a:rPr>
               <a:t>■ 1. CCS に対する folding scheme</a:t>
             </a:r>
-            <a:endParaRPr lang="en-US" sz="1600" dirty="0"/>
+            <a:endParaRPr lang="en-US" sz="1500" dirty="0"/>
           </a:p>
           <a:p>
             <a:pPr algn="l" lvl="1" indent="0" marL="0">
@@ -17002,7 +17002,7 @@
               <a:buNone/>
             </a:pPr>
             <a:r>
-              <a:rPr lang="en-US" sz="1300" dirty="0">
+              <a:rPr lang="en-US" sz="1200" dirty="0">
                 <a:solidFill>
                   <a:srgbClr val="282629"/>
                 </a:solidFill>
@@ -17012,7 +17012,7 @@
               </a:rPr>
               <a:t>  • R1CS / Plonkish / AIR を統一的に扱える</a:t>
             </a:r>
-            <a:endParaRPr lang="en-US" sz="1600" dirty="0"/>
+            <a:endParaRPr lang="en-US" sz="1500" dirty="0"/>
           </a:p>
           <a:p>
             <a:pPr algn="l" lvl="1" indent="0" marL="0">
@@ -17022,7 +17022,7 @@
               <a:buNone/>
             </a:pPr>
             <a:r>
-              <a:rPr lang="en-US" sz="1300" dirty="0">
+              <a:rPr lang="en-US" sz="1200" dirty="0">
                 <a:solidFill>
                   <a:srgbClr val="282629"/>
                 </a:solidFill>
@@ -17030,9 +17030,35 @@
                 <a:ea typeface="Yu Gothic" pitchFamily="34" charset="-122"/>
                 <a:cs typeface="Yu Gothic" pitchFamily="34" charset="-120"/>
               </a:rPr>
-              <a:t>  • prover cost = 1 回の MSM（変数数に比例）</a:t>
-            </a:r>
-            <a:endParaRPr lang="en-US" sz="1600" dirty="0"/>
+              <a:t>  • prover cost = 1 回の MSM（変数数 N に比例）</a:t>
+            </a:r>
+            <a:endParaRPr lang="en-US" sz="1500" dirty="0"/>
+          </a:p>
+          <a:p>
+            <a:pPr algn="l" indent="0" marL="0">
+              <a:buNone/>
+            </a:pPr>
+            <a:endParaRPr lang="en-US" sz="1500" dirty="0"/>
+          </a:p>
+          <a:p>
+            <a:pPr algn="l" indent="0" marL="0">
+              <a:spcBef>
+                <a:spcPts val="600"/>
+              </a:spcBef>
+              <a:buNone/>
+            </a:pPr>
+            <a:r>
+              <a:rPr lang="en-US" sz="1500" b="1" dirty="0">
+                <a:solidFill>
+                  <a:srgbClr val="3E7EC7"/>
+                </a:solidFill>
+                <a:latin typeface="Yu Gothic" pitchFamily="34" charset="0"/>
+                <a:ea typeface="Yu Gothic" pitchFamily="34" charset="-122"/>
+                <a:cs typeface="Yu Gothic" pitchFamily="34" charset="-120"/>
+              </a:rPr>
+              <a:t>■ 2. Multi-folding scheme</a:t>
+            </a:r>
+            <a:endParaRPr lang="en-US" sz="1500" dirty="0"/>
           </a:p>
           <a:p>
             <a:pPr algn="l" lvl="1" indent="0" marL="0">
@@ -17042,7 +17068,7 @@
               <a:buNone/>
             </a:pPr>
             <a:r>
-              <a:rPr lang="en-US" sz="1300" dirty="0">
+              <a:rPr lang="en-US" sz="1200" dirty="0">
                 <a:solidFill>
                   <a:srgbClr val="282629"/>
                 </a:solidFill>
@@ -17050,35 +17076,9 @@
                 <a:ea typeface="Yu Gothic" pitchFamily="34" charset="-122"/>
                 <a:cs typeface="Yu Gothic" pitchFamily="34" charset="-120"/>
               </a:rPr>
-              <a:t>  • Nova の |C| 比例コストを CCS の N 比例に改善</a:t>
-            </a:r>
-            <a:endParaRPr lang="en-US" sz="1600" dirty="0"/>
-          </a:p>
-          <a:p>
-            <a:pPr algn="l" indent="0" marL="0">
-              <a:buNone/>
-            </a:pPr>
-            <a:endParaRPr lang="en-US" sz="1600" dirty="0"/>
-          </a:p>
-          <a:p>
-            <a:pPr algn="l" indent="0" marL="0">
-              <a:spcBef>
-                <a:spcPts val="600"/>
-              </a:spcBef>
-              <a:buNone/>
-            </a:pPr>
-            <a:r>
-              <a:rPr lang="en-US" sz="1600" b="1" dirty="0">
-                <a:solidFill>
-                  <a:srgbClr val="3E7EC7"/>
-                </a:solidFill>
-                <a:latin typeface="Yu Gothic" pitchFamily="34" charset="0"/>
-                <a:ea typeface="Yu Gothic" pitchFamily="34" charset="-122"/>
-                <a:cs typeface="Yu Gothic" pitchFamily="34" charset="-120"/>
-              </a:rPr>
-              <a:t>■ 2. Multi-folding scheme</a:t>
-            </a:r>
-            <a:endParaRPr lang="en-US" sz="1600" dirty="0"/>
+              <a:t>  • 異なる構造を持つ NP relation を同時に 1 つの instance に fold</a:t>
+            </a:r>
+            <a:endParaRPr lang="en-US" sz="1500" dirty="0"/>
           </a:p>
           <a:p>
             <a:pPr algn="l" lvl="1" indent="0" marL="0">
@@ -17088,7 +17088,7 @@
               <a:buNone/>
             </a:pPr>
             <a:r>
-              <a:rPr lang="en-US" sz="1300" dirty="0">
+              <a:rPr lang="en-US" sz="1200" dirty="0">
                 <a:solidFill>
                   <a:srgbClr val="282629"/>
                 </a:solidFill>
@@ -17096,9 +17096,9 @@
                 <a:ea typeface="Yu Gothic" pitchFamily="34" charset="-122"/>
                 <a:cs typeface="Yu Gothic" pitchFamily="34" charset="-120"/>
               </a:rPr>
-              <a:t>  • 異なる構造を持つ NP relation を同時に 1 つの instance に fold</a:t>
-            </a:r>
-            <a:endParaRPr lang="en-US" sz="1600" dirty="0"/>
+              <a:t>  • 例: CCS instance + LCCS instance を 1 つの LCCS に集約</a:t>
+            </a:r>
+            <a:endParaRPr lang="en-US" sz="1500" dirty="0"/>
           </a:p>
           <a:p>
             <a:pPr algn="l" lvl="1" indent="0" marL="0">
@@ -17108,7 +17108,7 @@
               <a:buNone/>
             </a:pPr>
             <a:r>
-              <a:rPr lang="en-US" sz="1300" dirty="0">
+              <a:rPr lang="en-US" sz="1200" dirty="0">
                 <a:solidFill>
                   <a:srgbClr val="282629"/>
                 </a:solidFill>
@@ -17116,9 +17116,35 @@
                 <a:ea typeface="Yu Gothic" pitchFamily="34" charset="-122"/>
                 <a:cs typeface="Yu Gothic" pitchFamily="34" charset="-120"/>
               </a:rPr>
-              <a:t>  • ─ 例: CCS instance + LCCS instance を 1 つの LCCS に集約</a:t>
-            </a:r>
-            <a:endParaRPr lang="en-US" sz="1600" dirty="0"/>
+              <a:t>  • 非均一 IVC（SuperNova 系）の自然な一般化</a:t>
+            </a:r>
+            <a:endParaRPr lang="en-US" sz="1500" dirty="0"/>
+          </a:p>
+          <a:p>
+            <a:pPr algn="l" indent="0" marL="0">
+              <a:buNone/>
+            </a:pPr>
+            <a:endParaRPr lang="en-US" sz="1500" dirty="0"/>
+          </a:p>
+          <a:p>
+            <a:pPr algn="l" indent="0" marL="0">
+              <a:spcBef>
+                <a:spcPts val="600"/>
+              </a:spcBef>
+              <a:buNone/>
+            </a:pPr>
+            <a:r>
+              <a:rPr lang="en-US" sz="1500" b="1" dirty="0">
+                <a:solidFill>
+                  <a:srgbClr val="3E7EC7"/>
+                </a:solidFill>
+                <a:latin typeface="Yu Gothic" pitchFamily="34" charset="0"/>
+                <a:ea typeface="Yu Gothic" pitchFamily="34" charset="-122"/>
+                <a:cs typeface="Yu Gothic" pitchFamily="34" charset="-120"/>
+              </a:rPr>
+              <a:t>■ 3. CycleFold ── 楕円曲線サイクルの汎用化</a:t>
+            </a:r>
+            <a:endParaRPr lang="en-US" sz="1500" dirty="0"/>
           </a:p>
           <a:p>
             <a:pPr algn="l" lvl="1" indent="0" marL="0">
@@ -17128,7 +17154,7 @@
               <a:buNone/>
             </a:pPr>
             <a:r>
-              <a:rPr lang="en-US" sz="1300" dirty="0">
+              <a:rPr lang="en-US" sz="1200" dirty="0">
                 <a:solidFill>
                   <a:srgbClr val="282629"/>
                 </a:solidFill>
@@ -17136,35 +17162,9 @@
                 <a:ea typeface="Yu Gothic" pitchFamily="34" charset="-122"/>
                 <a:cs typeface="Yu Gothic" pitchFamily="34" charset="-120"/>
               </a:rPr>
-              <a:t>  • ─ 非均一 IVC（SuperNova 系）の自然な一般化</a:t>
-            </a:r>
-            <a:endParaRPr lang="en-US" sz="1600" dirty="0"/>
-          </a:p>
-          <a:p>
-            <a:pPr algn="l" indent="0" marL="0">
-              <a:buNone/>
-            </a:pPr>
-            <a:endParaRPr lang="en-US" sz="1600" dirty="0"/>
-          </a:p>
-          <a:p>
-            <a:pPr algn="l" indent="0" marL="0">
-              <a:spcBef>
-                <a:spcPts val="600"/>
-              </a:spcBef>
-              <a:buNone/>
-            </a:pPr>
-            <a:r>
-              <a:rPr lang="en-US" sz="1600" b="1" dirty="0">
-                <a:solidFill>
-                  <a:srgbClr val="3E7EC7"/>
-                </a:solidFill>
-                <a:latin typeface="Yu Gothic" pitchFamily="34" charset="0"/>
-                <a:ea typeface="Yu Gothic" pitchFamily="34" charset="-122"/>
-                <a:cs typeface="Yu Gothic" pitchFamily="34" charset="-120"/>
-              </a:rPr>
-              <a:t>■ 3. CycleFold ── 楕円曲線サイクルの汎用化</a:t>
-            </a:r>
-            <a:endParaRPr lang="en-US" sz="1600" dirty="0"/>
+              <a:t>  • Nova / SuperNova / HyperNova いずれでも再利用可能</a:t>
+            </a:r>
+            <a:endParaRPr lang="en-US" sz="1500" dirty="0"/>
           </a:p>
           <a:p>
             <a:pPr algn="l" lvl="1" indent="0" marL="0">
@@ -17174,7 +17174,7 @@
               <a:buNone/>
             </a:pPr>
             <a:r>
-              <a:rPr lang="en-US" sz="1300" dirty="0">
+              <a:rPr lang="en-US" sz="1200" dirty="0">
                 <a:solidFill>
                   <a:srgbClr val="282629"/>
                 </a:solidFill>
@@ -17182,9 +17182,35 @@
                 <a:ea typeface="Yu Gothic" pitchFamily="34" charset="-122"/>
                 <a:cs typeface="Yu Gothic" pitchFamily="34" charset="-120"/>
               </a:rPr>
-              <a:t>  • 任意の modern folding-scheme ベース再帰 SNARK に適用可</a:t>
-            </a:r>
-            <a:endParaRPr lang="en-US" sz="1600" dirty="0"/>
+              <a:t>  • IVC を楕円曲線サイクル上で構成するときの共通インフラ</a:t>
+            </a:r>
+            <a:endParaRPr lang="en-US" sz="1500" dirty="0"/>
+          </a:p>
+          <a:p>
+            <a:pPr algn="l" indent="0" marL="0">
+              <a:buNone/>
+            </a:pPr>
+            <a:endParaRPr lang="en-US" sz="1500" dirty="0"/>
+          </a:p>
+          <a:p>
+            <a:pPr algn="l" indent="0" marL="0">
+              <a:spcBef>
+                <a:spcPts val="600"/>
+              </a:spcBef>
+              <a:buNone/>
+            </a:pPr>
+            <a:r>
+              <a:rPr lang="en-US" sz="1500" b="1" dirty="0">
+                <a:solidFill>
+                  <a:srgbClr val="3E7EC7"/>
+                </a:solidFill>
+                <a:latin typeface="Yu Gothic" pitchFamily="34" charset="0"/>
+                <a:ea typeface="Yu Gothic" pitchFamily="34" charset="-122"/>
+                <a:cs typeface="Yu Gothic" pitchFamily="34" charset="-120"/>
+              </a:rPr>
+              <a:t>■ 4. NovaBlindFold ── ZK を SNARK なしで追加</a:t>
+            </a:r>
+            <a:endParaRPr lang="en-US" sz="1500" dirty="0"/>
           </a:p>
           <a:p>
             <a:pPr algn="l" lvl="1" indent="0" marL="0">
@@ -17194,7 +17220,7 @@
               <a:buNone/>
             </a:pPr>
             <a:r>
-              <a:rPr lang="en-US" sz="1300" dirty="0">
+              <a:rPr lang="en-US" sz="1200" dirty="0">
                 <a:solidFill>
                   <a:srgbClr val="282629"/>
                 </a:solidFill>
@@ -17202,9 +17228,9 @@
                 <a:ea typeface="Yu Gothic" pitchFamily="34" charset="-122"/>
                 <a:cs typeface="Yu Gothic" pitchFamily="34" charset="-120"/>
               </a:rPr>
-              <a:t>  • ─ Nova / SuperNova / HyperNova いずれでも再利用可能</a:t>
-            </a:r>
-            <a:endParaRPr lang="en-US" sz="1600" dirty="0"/>
+              <a:t>  • Nova 自身が持つ blinding 性質を利用</a:t>
+            </a:r>
+            <a:endParaRPr lang="en-US" sz="1500" dirty="0"/>
           </a:p>
           <a:p>
             <a:pPr algn="l" lvl="1" indent="0" marL="0">
@@ -17214,7 +17240,7 @@
               <a:buNone/>
             </a:pPr>
             <a:r>
-              <a:rPr lang="en-US" sz="1300" dirty="0">
+              <a:rPr lang="en-US" sz="1200" dirty="0">
                 <a:solidFill>
                   <a:srgbClr val="282629"/>
                 </a:solidFill>
@@ -17222,35 +17248,9 @@
                 <a:ea typeface="Yu Gothic" pitchFamily="34" charset="-122"/>
                 <a:cs typeface="Yu Gothic" pitchFamily="34" charset="-120"/>
               </a:rPr>
-              <a:t>  • ─ IVC を楕円曲線サイクル上で構成するときの共通インフラ</a:t>
-            </a:r>
-            <a:endParaRPr lang="en-US" sz="1600" dirty="0"/>
-          </a:p>
-          <a:p>
-            <a:pPr algn="l" indent="0" marL="0">
-              <a:buNone/>
-            </a:pPr>
-            <a:endParaRPr lang="en-US" sz="1600" dirty="0"/>
-          </a:p>
-          <a:p>
-            <a:pPr algn="l" indent="0" marL="0">
-              <a:spcBef>
-                <a:spcPts val="600"/>
-              </a:spcBef>
-              <a:buNone/>
-            </a:pPr>
-            <a:r>
-              <a:rPr lang="en-US" sz="1600" b="1" dirty="0">
-                <a:solidFill>
-                  <a:srgbClr val="3E7EC7"/>
-                </a:solidFill>
-                <a:latin typeface="Yu Gothic" pitchFamily="34" charset="0"/>
-                <a:ea typeface="Yu Gothic" pitchFamily="34" charset="-122"/>
-                <a:cs typeface="Yu Gothic" pitchFamily="34" charset="-120"/>
-              </a:rPr>
-              <a:t>■ 4. NovaBlindFold ── ZK を SNARK なしで追加</a:t>
-            </a:r>
-            <a:endParaRPr lang="en-US" sz="1600" dirty="0"/>
+              <a:t>  • 別途 zk-SNARK を被さずに IVC 証明をゼロ知識化</a:t>
+            </a:r>
+            <a:endParaRPr lang="en-US" sz="1500" dirty="0"/>
           </a:p>
           <a:p>
             <a:pPr algn="l" lvl="1" indent="0" marL="0">
@@ -17260,7 +17260,7 @@
               <a:buNone/>
             </a:pPr>
             <a:r>
-              <a:rPr lang="en-US" sz="1300" dirty="0">
+              <a:rPr lang="en-US" sz="1200" dirty="0">
                 <a:solidFill>
                   <a:srgbClr val="282629"/>
                 </a:solidFill>
@@ -17268,49 +17268,9 @@
                 <a:ea typeface="Yu Gothic" pitchFamily="34" charset="-122"/>
                 <a:cs typeface="Yu Gothic" pitchFamily="34" charset="-120"/>
               </a:rPr>
-              <a:t>  • Nova 自身が持つ blinding 性質を利用</a:t>
-            </a:r>
-            <a:endParaRPr lang="en-US" sz="1600" dirty="0"/>
-          </a:p>
-          <a:p>
-            <a:pPr algn="l" lvl="1" indent="0" marL="0">
-              <a:spcBef>
-                <a:spcPts val="300"/>
-              </a:spcBef>
-              <a:buNone/>
-            </a:pPr>
-            <a:r>
-              <a:rPr lang="en-US" sz="1300" dirty="0">
-                <a:solidFill>
-                  <a:srgbClr val="282629"/>
-                </a:solidFill>
-                <a:latin typeface="Yu Gothic" pitchFamily="34" charset="0"/>
-                <a:ea typeface="Yu Gothic" pitchFamily="34" charset="-122"/>
-                <a:cs typeface="Yu Gothic" pitchFamily="34" charset="-120"/>
-              </a:rPr>
-              <a:t>  • ─ 別途 zk-SNARK を被せずに IVC 証明をゼロ知識化</a:t>
-            </a:r>
-            <a:endParaRPr lang="en-US" sz="1600" dirty="0"/>
-          </a:p>
-          <a:p>
-            <a:pPr algn="l" lvl="1" indent="0" marL="0">
-              <a:spcBef>
-                <a:spcPts val="300"/>
-              </a:spcBef>
-              <a:buNone/>
-            </a:pPr>
-            <a:r>
-              <a:rPr lang="en-US" sz="1300" dirty="0">
-                <a:solidFill>
-                  <a:srgbClr val="282629"/>
-                </a:solidFill>
-                <a:latin typeface="Yu Gothic" pitchFamily="34" charset="0"/>
-                <a:ea typeface="Yu Gothic" pitchFamily="34" charset="-122"/>
-                <a:cs typeface="Yu Gothic" pitchFamily="34" charset="-120"/>
-              </a:rPr>
-              <a:t>  • ─ 実装コスト・回路サイズの双方を削減</a:t>
-            </a:r>
-            <a:endParaRPr lang="en-US" sz="1600" dirty="0"/>
+              <a:t>  • 実装コスト・回路サイズの双方を削減</a:t>
+            </a:r>
+            <a:endParaRPr lang="en-US" sz="1500" dirty="0"/>
           </a:p>
         </p:txBody>
       </p:sp>

</xml_diff>

<commit_message>
Fix overlap on slide-14 and tidy slide-07 subtitle
- slide-14: replace multi-line ポイント with single-line ◆ R1CS/CCS contrast
- slide-07: shorten folding-scheme subtitle so 'ンプリミティブ' no longer wraps
</commit_message>
<xml_diff>
--- a/docs/pptx/hypernova-rinkou.pptx
+++ b/docs/pptx/hypernova-rinkou.pptx
@@ -8121,8 +8121,8 @@
         </p:nvSpPr>
         <p:spPr>
           <a:xfrm>
-            <a:off x="393192" y="6263640"/>
-            <a:ext cx="8284464" cy="274320"/>
+            <a:off x="393192" y="6355080"/>
+            <a:ext cx="7772400" cy="365760"/>
           </a:xfrm>
           <a:prstGeom prst="rect">
             <a:avLst/>
@@ -8131,28 +8131,28 @@
           <a:ln/>
         </p:spPr>
         <p:txBody>
-          <a:bodyPr wrap="square" rtlCol="0" anchor="ctr"/>
+          <a:bodyPr wrap="square" lIns="0" tIns="0" rIns="0" bIns="0" rtlCol="0" anchor="ctr"/>
           <a:lstStyle/>
           <a:p>
             <a:pPr algn="l" indent="0" marL="0">
               <a:buNone/>
             </a:pPr>
             <a:r>
-              <a:rPr lang="en-US" sz="1200" b="1" dirty="0">
-                <a:solidFill>
-                  <a:srgbClr val="282629"/>
-                </a:solidFill>
-                <a:latin typeface="Yu Gothic" pitchFamily="34" charset="0"/>
-                <a:ea typeface="Yu Gothic" pitchFamily="34" charset="-122"/>
-                <a:cs typeface="Yu Gothic" pitchFamily="34" charset="-120"/>
-              </a:rPr>
-              <a:t>ポイント：</a:t>
-            </a:r>
-            <a:pPr algn="l" indent="0" marL="0">
-              <a:buNone/>
-            </a:pPr>
-            <a:r>
-              <a:rPr lang="en-US" sz="1200" dirty="0">
+              <a:rPr lang="en-US" sz="1100" b="1" dirty="0">
+                <a:solidFill>
+                  <a:srgbClr val="3E7EC7"/>
+                </a:solidFill>
+                <a:latin typeface="Yu Gothic" pitchFamily="34" charset="0"/>
+                <a:ea typeface="Yu Gothic" pitchFamily="34" charset="-122"/>
+                <a:cs typeface="Yu Gothic" pitchFamily="34" charset="-120"/>
+              </a:rPr>
+              <a:t>◆ </a:t>
+            </a:r>
+            <a:pPr algn="l" indent="0" marL="0">
+              <a:buNone/>
+            </a:pPr>
+            <a:r>
+              <a:rPr lang="en-US" sz="1100" dirty="0">
                 <a:solidFill>
                   <a:srgbClr val="000000"/>
                 </a:solidFill>
@@ -8160,13 +8160,13 @@
                 <a:ea typeface="Yu Gothic" pitchFamily="34" charset="-122"/>
                 <a:cs typeface="Yu Gothic" pitchFamily="34" charset="-120"/>
               </a:rPr>
-              <a:t> Nova は </a:t>
-            </a:r>
-            <a:pPr algn="l" indent="0" marL="0">
-              <a:buNone/>
-            </a:pPr>
-            <a:r>
-              <a:rPr lang="en-US" sz="1200" i="1" dirty="0">
+              <a:t>Nova は </a:t>
+            </a:r>
+            <a:pPr algn="l" indent="0" marL="0">
+              <a:buNone/>
+            </a:pPr>
+            <a:r>
+              <a:rPr lang="en-US" sz="1100" i="1" dirty="0">
                 <a:solidFill>
                   <a:srgbClr val="000000"/>
                 </a:solidFill>
@@ -8180,7 +8180,7 @@
               <a:buNone/>
             </a:pPr>
             <a:r>
-              <a:rPr lang="en-US" sz="1200" dirty="0">
+              <a:rPr lang="en-US" sz="1100" dirty="0">
                 <a:solidFill>
                   <a:srgbClr val="000000"/>
                 </a:solidFill>
@@ -8188,13 +8188,13 @@
                 <a:ea typeface="Yu Gothic" pitchFamily="34" charset="-122"/>
                 <a:cs typeface="Yu Gothic" pitchFamily="34" charset="-120"/>
               </a:rPr>
-              <a:t> に閉じていた。HyperNova は </a:t>
-            </a:r>
-            <a:pPr algn="l" indent="0" marL="0">
-              <a:buNone/>
-            </a:pPr>
-            <a:r>
-              <a:rPr lang="en-US" sz="1200" i="1" dirty="0">
+              <a:t> 専用 / HyperNova は </a:t>
+            </a:r>
+            <a:pPr algn="l" indent="0" marL="0">
+              <a:buNone/>
+            </a:pPr>
+            <a:r>
+              <a:rPr lang="en-US" sz="1100" i="1" dirty="0">
                 <a:solidFill>
                   <a:srgbClr val="000000"/>
                 </a:solidFill>
@@ -8208,7 +8208,7 @@
               <a:buNone/>
             </a:pPr>
             <a:r>
-              <a:rPr lang="en-US" sz="1200" dirty="0">
+              <a:rPr lang="en-US" sz="1100" dirty="0">
                 <a:solidFill>
                   <a:srgbClr val="000000"/>
                 </a:solidFill>
@@ -8216,23 +8216,9 @@
                 <a:ea typeface="Yu Gothic" pitchFamily="34" charset="-122"/>
                 <a:cs typeface="Yu Gothic" pitchFamily="34" charset="-120"/>
               </a:rPr>
-              <a:t> で同じコスト特性を実現 ── </a:t>
-            </a:r>
-            <a:pPr algn="l" indent="0" marL="0">
-              <a:buNone/>
-            </a:pPr>
-            <a:r>
-              <a:rPr lang="en-US" sz="1200" i="1" dirty="0">
-                <a:solidFill>
-                  <a:srgbClr val="3E7EC7"/>
-                </a:solidFill>
-                <a:latin typeface="Yu Gothic" pitchFamily="34" charset="0"/>
-                <a:ea typeface="Yu Gothic" pitchFamily="34" charset="-122"/>
-                <a:cs typeface="Yu Gothic" pitchFamily="34" charset="-120"/>
-              </a:rPr>
-              <a:t>これが Slide 8 の「1 MSM」の主張</a:t>
-            </a:r>
-            <a:endParaRPr lang="en-US" sz="1200" dirty="0"/>
+              <a:t> で同じ O(1)·MSM コスト</a:t>
+            </a:r>
+            <a:endParaRPr lang="en-US" sz="1100" dirty="0"/>
           </a:p>
         </p:txBody>
       </p:sp>
@@ -16020,7 +16006,7 @@
                 <a:ea typeface="Yu Gothic" pitchFamily="34" charset="-122"/>
                 <a:cs typeface="Yu Gothic" pitchFamily="34" charset="-120"/>
               </a:rPr>
-              <a:t>（2 つの instance を 1 つの instance に reduce する暗号プリミティブ）</a:t>
+              <a:t>（2 つの instance を 1 つに reduce する暗号プリミティブ）</a:t>
             </a:r>
             <a:endParaRPr lang="en-US" sz="2000" dirty="0"/>
           </a:p>

</xml_diff>

<commit_message>
Remove auto slide numbers so user can set them manually in PowerPoint
- dropped drawPageNumber(slide, N) call from slide-02..16 (15 files)
- removed unused slide-ref-rules.js (compile.js only loads 01..16)
- OneDrive + GitHub Pages rebroadcast
</commit_message>
<xml_diff>
--- a/docs/pptx/hypernova-rinkou.pptx
+++ b/docs/pptx/hypernova-rinkou.pptx
@@ -5087,45 +5087,6 @@
           </a:p>
         </p:txBody>
       </p:sp>
-      <p:sp>
-        <p:nvSpPr>
-          <p:cNvPr id="9" name="Text 6"/>
-          <p:cNvSpPr/>
-          <p:nvPr/>
-        </p:nvSpPr>
-        <p:spPr>
-          <a:xfrm>
-            <a:off x="393192" y="6601968"/>
-            <a:ext cx="539496" cy="182880"/>
-          </a:xfrm>
-          <a:prstGeom prst="rect">
-            <a:avLst/>
-          </a:prstGeom>
-          <a:noFill/>
-          <a:ln/>
-        </p:spPr>
-        <p:txBody>
-          <a:bodyPr wrap="square" rtlCol="0" anchor="ctr"/>
-          <a:lstStyle/>
-          <a:p>
-            <a:pPr algn="l" indent="0" marL="0">
-              <a:buNone/>
-            </a:pPr>
-            <a:r>
-              <a:rPr lang="en-US" sz="1400" b="1" dirty="0">
-                <a:solidFill>
-                  <a:srgbClr val="282629"/>
-                </a:solidFill>
-                <a:latin typeface="Calibri" pitchFamily="34" charset="0"/>
-                <a:ea typeface="Calibri" pitchFamily="34" charset="-122"/>
-                <a:cs typeface="Calibri" pitchFamily="34" charset="-120"/>
-              </a:rPr>
-              <a:t>10</a:t>
-            </a:r>
-            <a:endParaRPr lang="en-US" sz="1400" dirty="0"/>
-          </a:p>
-        </p:txBody>
-      </p:sp>
     </p:spTree>
   </p:cSld>
   <p:clrMapOvr>
@@ -5790,45 +5751,6 @@
           </a:p>
         </p:txBody>
       </p:sp>
-      <p:sp>
-        <p:nvSpPr>
-          <p:cNvPr id="22" name="Text 20"/>
-          <p:cNvSpPr/>
-          <p:nvPr/>
-        </p:nvSpPr>
-        <p:spPr>
-          <a:xfrm>
-            <a:off x="393192" y="6601968"/>
-            <a:ext cx="539496" cy="182880"/>
-          </a:xfrm>
-          <a:prstGeom prst="rect">
-            <a:avLst/>
-          </a:prstGeom>
-          <a:noFill/>
-          <a:ln/>
-        </p:spPr>
-        <p:txBody>
-          <a:bodyPr wrap="square" rtlCol="0" anchor="ctr"/>
-          <a:lstStyle/>
-          <a:p>
-            <a:pPr algn="l" indent="0" marL="0">
-              <a:buNone/>
-            </a:pPr>
-            <a:r>
-              <a:rPr lang="en-US" sz="1400" b="1" dirty="0">
-                <a:solidFill>
-                  <a:srgbClr val="282629"/>
-                </a:solidFill>
-                <a:latin typeface="Calibri" pitchFamily="34" charset="0"/>
-                <a:ea typeface="Calibri" pitchFamily="34" charset="-122"/>
-                <a:cs typeface="Calibri" pitchFamily="34" charset="-120"/>
-              </a:rPr>
-              <a:t>11</a:t>
-            </a:r>
-            <a:endParaRPr lang="en-US" sz="1400" dirty="0"/>
-          </a:p>
-        </p:txBody>
-      </p:sp>
     </p:spTree>
   </p:cSld>
   <p:clrMapOvr>
@@ -6288,45 +6210,6 @@
           </a:ln>
         </p:spPr>
       </p:sp>
-      <p:sp>
-        <p:nvSpPr>
-          <p:cNvPr id="9" name="Text 7"/>
-          <p:cNvSpPr/>
-          <p:nvPr/>
-        </p:nvSpPr>
-        <p:spPr>
-          <a:xfrm>
-            <a:off x="393192" y="6601968"/>
-            <a:ext cx="539496" cy="182880"/>
-          </a:xfrm>
-          <a:prstGeom prst="rect">
-            <a:avLst/>
-          </a:prstGeom>
-          <a:noFill/>
-          <a:ln/>
-        </p:spPr>
-        <p:txBody>
-          <a:bodyPr wrap="square" rtlCol="0" anchor="ctr"/>
-          <a:lstStyle/>
-          <a:p>
-            <a:pPr algn="l" indent="0" marL="0">
-              <a:buNone/>
-            </a:pPr>
-            <a:r>
-              <a:rPr lang="en-US" sz="1400" b="1" dirty="0">
-                <a:solidFill>
-                  <a:srgbClr val="282629"/>
-                </a:solidFill>
-                <a:latin typeface="Calibri" pitchFamily="34" charset="0"/>
-                <a:ea typeface="Calibri" pitchFamily="34" charset="-122"/>
-                <a:cs typeface="Calibri" pitchFamily="34" charset="-120"/>
-              </a:rPr>
-              <a:t>12</a:t>
-            </a:r>
-            <a:endParaRPr lang="en-US" sz="1400" dirty="0"/>
-          </a:p>
-        </p:txBody>
-      </p:sp>
     </p:spTree>
   </p:cSld>
   <p:clrMapOvr>
@@ -6789,45 +6672,6 @@
           </a:p>
         </p:txBody>
       </p:sp>
-      <p:sp>
-        <p:nvSpPr>
-          <p:cNvPr id="11" name="Text 9"/>
-          <p:cNvSpPr/>
-          <p:nvPr/>
-        </p:nvSpPr>
-        <p:spPr>
-          <a:xfrm>
-            <a:off x="393192" y="6601968"/>
-            <a:ext cx="539496" cy="182880"/>
-          </a:xfrm>
-          <a:prstGeom prst="rect">
-            <a:avLst/>
-          </a:prstGeom>
-          <a:noFill/>
-          <a:ln/>
-        </p:spPr>
-        <p:txBody>
-          <a:bodyPr wrap="square" rtlCol="0" anchor="ctr"/>
-          <a:lstStyle/>
-          <a:p>
-            <a:pPr algn="l" indent="0" marL="0">
-              <a:buNone/>
-            </a:pPr>
-            <a:r>
-              <a:rPr lang="en-US" sz="1400" b="1" dirty="0">
-                <a:solidFill>
-                  <a:srgbClr val="282629"/>
-                </a:solidFill>
-                <a:latin typeface="Calibri" pitchFamily="34" charset="0"/>
-                <a:ea typeface="Calibri" pitchFamily="34" charset="-122"/>
-                <a:cs typeface="Calibri" pitchFamily="34" charset="-120"/>
-              </a:rPr>
-              <a:t>13</a:t>
-            </a:r>
-            <a:endParaRPr lang="en-US" sz="1400" dirty="0"/>
-          </a:p>
-        </p:txBody>
-      </p:sp>
     </p:spTree>
   </p:cSld>
   <p:clrMapOvr>
@@ -8222,45 +8066,6 @@
           </a:p>
         </p:txBody>
       </p:sp>
-      <p:sp>
-        <p:nvSpPr>
-          <p:cNvPr id="10" name="Text 8"/>
-          <p:cNvSpPr/>
-          <p:nvPr/>
-        </p:nvSpPr>
-        <p:spPr>
-          <a:xfrm>
-            <a:off x="393192" y="6601968"/>
-            <a:ext cx="539496" cy="182880"/>
-          </a:xfrm>
-          <a:prstGeom prst="rect">
-            <a:avLst/>
-          </a:prstGeom>
-          <a:noFill/>
-          <a:ln/>
-        </p:spPr>
-        <p:txBody>
-          <a:bodyPr wrap="square" rtlCol="0" anchor="ctr"/>
-          <a:lstStyle/>
-          <a:p>
-            <a:pPr algn="l" indent="0" marL="0">
-              <a:buNone/>
-            </a:pPr>
-            <a:r>
-              <a:rPr lang="en-US" sz="1400" b="1" dirty="0">
-                <a:solidFill>
-                  <a:srgbClr val="282629"/>
-                </a:solidFill>
-                <a:latin typeface="Calibri" pitchFamily="34" charset="0"/>
-                <a:ea typeface="Calibri" pitchFamily="34" charset="-122"/>
-                <a:cs typeface="Calibri" pitchFamily="34" charset="-120"/>
-              </a:rPr>
-              <a:t>14</a:t>
-            </a:r>
-            <a:endParaRPr lang="en-US" sz="1400" dirty="0"/>
-          </a:p>
-        </p:txBody>
-      </p:sp>
     </p:spTree>
   </p:cSld>
   <p:clrMapOvr>
@@ -9250,45 +9055,6 @@
                 <a:cs typeface="Yu Gothic" pitchFamily="34" charset="-120"/>
               </a:rPr>
               <a:t> ── 上の Fold(π, ρ) だけで ZK 化（回路サイズ小）</a:t>
-            </a:r>
-            <a:endParaRPr lang="en-US" sz="1400" dirty="0"/>
-          </a:p>
-        </p:txBody>
-      </p:sp>
-      <p:sp>
-        <p:nvSpPr>
-          <p:cNvPr id="9" name="Text 7"/>
-          <p:cNvSpPr/>
-          <p:nvPr/>
-        </p:nvSpPr>
-        <p:spPr>
-          <a:xfrm>
-            <a:off x="393192" y="6601968"/>
-            <a:ext cx="539496" cy="182880"/>
-          </a:xfrm>
-          <a:prstGeom prst="rect">
-            <a:avLst/>
-          </a:prstGeom>
-          <a:noFill/>
-          <a:ln/>
-        </p:spPr>
-        <p:txBody>
-          <a:bodyPr wrap="square" rtlCol="0" anchor="ctr"/>
-          <a:lstStyle/>
-          <a:p>
-            <a:pPr algn="l" indent="0" marL="0">
-              <a:buNone/>
-            </a:pPr>
-            <a:r>
-              <a:rPr lang="en-US" sz="1400" b="1" dirty="0">
-                <a:solidFill>
-                  <a:srgbClr val="282629"/>
-                </a:solidFill>
-                <a:latin typeface="Calibri" pitchFamily="34" charset="0"/>
-                <a:ea typeface="Calibri" pitchFamily="34" charset="-122"/>
-                <a:cs typeface="Calibri" pitchFamily="34" charset="-120"/>
-              </a:rPr>
-              <a:t>15</a:t>
             </a:r>
             <a:endParaRPr lang="en-US" sz="1400" dirty="0"/>
           </a:p>
@@ -11577,45 +11343,6 @@
           </a:p>
         </p:txBody>
       </p:sp>
-      <p:sp>
-        <p:nvSpPr>
-          <p:cNvPr id="9" name="Text 6"/>
-          <p:cNvSpPr/>
-          <p:nvPr/>
-        </p:nvSpPr>
-        <p:spPr>
-          <a:xfrm>
-            <a:off x="393192" y="6601968"/>
-            <a:ext cx="539496" cy="182880"/>
-          </a:xfrm>
-          <a:prstGeom prst="rect">
-            <a:avLst/>
-          </a:prstGeom>
-          <a:noFill/>
-          <a:ln/>
-        </p:spPr>
-        <p:txBody>
-          <a:bodyPr wrap="square" rtlCol="0" anchor="ctr"/>
-          <a:lstStyle/>
-          <a:p>
-            <a:pPr algn="l" indent="0" marL="0">
-              <a:buNone/>
-            </a:pPr>
-            <a:r>
-              <a:rPr lang="en-US" sz="1400" b="1" dirty="0">
-                <a:solidFill>
-                  <a:srgbClr val="282629"/>
-                </a:solidFill>
-                <a:latin typeface="Calibri" pitchFamily="34" charset="0"/>
-                <a:ea typeface="Calibri" pitchFamily="34" charset="-122"/>
-                <a:cs typeface="Calibri" pitchFamily="34" charset="-120"/>
-              </a:rPr>
-              <a:t>16</a:t>
-            </a:r>
-            <a:endParaRPr lang="en-US" sz="1400" dirty="0"/>
-          </a:p>
-        </p:txBody>
-      </p:sp>
     </p:spTree>
   </p:cSld>
   <p:clrMapOvr>
@@ -11911,45 +11638,6 @@
           </a:p>
         </p:txBody>
       </p:sp>
-      <p:sp>
-        <p:nvSpPr>
-          <p:cNvPr id="5" name="Text 3"/>
-          <p:cNvSpPr/>
-          <p:nvPr/>
-        </p:nvSpPr>
-        <p:spPr>
-          <a:xfrm>
-            <a:off x="393192" y="6601968"/>
-            <a:ext cx="539496" cy="182880"/>
-          </a:xfrm>
-          <a:prstGeom prst="rect">
-            <a:avLst/>
-          </a:prstGeom>
-          <a:noFill/>
-          <a:ln/>
-        </p:spPr>
-        <p:txBody>
-          <a:bodyPr wrap="square" rtlCol="0" anchor="ctr"/>
-          <a:lstStyle/>
-          <a:p>
-            <a:pPr algn="l" indent="0" marL="0">
-              <a:buNone/>
-            </a:pPr>
-            <a:r>
-              <a:rPr lang="en-US" sz="1400" b="1" dirty="0">
-                <a:solidFill>
-                  <a:srgbClr val="282629"/>
-                </a:solidFill>
-                <a:latin typeface="Calibri" pitchFamily="34" charset="0"/>
-                <a:ea typeface="Calibri" pitchFamily="34" charset="-122"/>
-                <a:cs typeface="Calibri" pitchFamily="34" charset="-120"/>
-              </a:rPr>
-              <a:t>2</a:t>
-            </a:r>
-            <a:endParaRPr lang="en-US" sz="1400" dirty="0"/>
-          </a:p>
-        </p:txBody>
-      </p:sp>
     </p:spTree>
   </p:cSld>
   <p:clrMapOvr>
@@ -12356,45 +12044,6 @@
           </a:p>
         </p:txBody>
       </p:sp>
-      <p:sp>
-        <p:nvSpPr>
-          <p:cNvPr id="7" name="Text 5"/>
-          <p:cNvSpPr/>
-          <p:nvPr/>
-        </p:nvSpPr>
-        <p:spPr>
-          <a:xfrm>
-            <a:off x="393192" y="6601968"/>
-            <a:ext cx="539496" cy="182880"/>
-          </a:xfrm>
-          <a:prstGeom prst="rect">
-            <a:avLst/>
-          </a:prstGeom>
-          <a:noFill/>
-          <a:ln/>
-        </p:spPr>
-        <p:txBody>
-          <a:bodyPr wrap="square" rtlCol="0" anchor="ctr"/>
-          <a:lstStyle/>
-          <a:p>
-            <a:pPr algn="l" indent="0" marL="0">
-              <a:buNone/>
-            </a:pPr>
-            <a:r>
-              <a:rPr lang="en-US" sz="1400" b="1" dirty="0">
-                <a:solidFill>
-                  <a:srgbClr val="282629"/>
-                </a:solidFill>
-                <a:latin typeface="Calibri" pitchFamily="34" charset="0"/>
-                <a:ea typeface="Calibri" pitchFamily="34" charset="-122"/>
-                <a:cs typeface="Calibri" pitchFamily="34" charset="-120"/>
-              </a:rPr>
-              <a:t>3</a:t>
-            </a:r>
-            <a:endParaRPr lang="en-US" sz="1400" dirty="0"/>
-          </a:p>
-        </p:txBody>
-      </p:sp>
     </p:spTree>
   </p:cSld>
   <p:clrMapOvr>
@@ -12824,45 +12473,6 @@
               <a:t>※ HyperNova は SNARK そのものではなく「SNARK の合成法」を提案する論文。</a:t>
             </a:r>
             <a:endParaRPr lang="en-US" sz="1200" dirty="0"/>
-          </a:p>
-        </p:txBody>
-      </p:sp>
-      <p:sp>
-        <p:nvSpPr>
-          <p:cNvPr id="8" name="Text 6"/>
-          <p:cNvSpPr/>
-          <p:nvPr/>
-        </p:nvSpPr>
-        <p:spPr>
-          <a:xfrm>
-            <a:off x="393192" y="6601968"/>
-            <a:ext cx="539496" cy="182880"/>
-          </a:xfrm>
-          <a:prstGeom prst="rect">
-            <a:avLst/>
-          </a:prstGeom>
-          <a:noFill/>
-          <a:ln/>
-        </p:spPr>
-        <p:txBody>
-          <a:bodyPr wrap="square" rtlCol="0" anchor="ctr"/>
-          <a:lstStyle/>
-          <a:p>
-            <a:pPr algn="l" indent="0" marL="0">
-              <a:buNone/>
-            </a:pPr>
-            <a:r>
-              <a:rPr lang="en-US" sz="1400" b="1" dirty="0">
-                <a:solidFill>
-                  <a:srgbClr val="282629"/>
-                </a:solidFill>
-                <a:latin typeface="Calibri" pitchFamily="34" charset="0"/>
-                <a:ea typeface="Calibri" pitchFamily="34" charset="-122"/>
-                <a:cs typeface="Calibri" pitchFamily="34" charset="-120"/>
-              </a:rPr>
-              <a:t>4</a:t>
-            </a:r>
-            <a:endParaRPr lang="en-US" sz="1400" dirty="0"/>
           </a:p>
         </p:txBody>
       </p:sp>
@@ -14581,45 +14191,6 @@
           </a:p>
         </p:txBody>
       </p:sp>
-      <p:sp>
-        <p:nvSpPr>
-          <p:cNvPr id="9" name="Text 6"/>
-          <p:cNvSpPr/>
-          <p:nvPr/>
-        </p:nvSpPr>
-        <p:spPr>
-          <a:xfrm>
-            <a:off x="393192" y="6601968"/>
-            <a:ext cx="539496" cy="182880"/>
-          </a:xfrm>
-          <a:prstGeom prst="rect">
-            <a:avLst/>
-          </a:prstGeom>
-          <a:noFill/>
-          <a:ln/>
-        </p:spPr>
-        <p:txBody>
-          <a:bodyPr wrap="square" rtlCol="0" anchor="ctr"/>
-          <a:lstStyle/>
-          <a:p>
-            <a:pPr algn="l" indent="0" marL="0">
-              <a:buNone/>
-            </a:pPr>
-            <a:r>
-              <a:rPr lang="en-US" sz="1400" b="1" dirty="0">
-                <a:solidFill>
-                  <a:srgbClr val="282629"/>
-                </a:solidFill>
-                <a:latin typeface="Calibri" pitchFamily="34" charset="0"/>
-                <a:ea typeface="Calibri" pitchFamily="34" charset="-122"/>
-                <a:cs typeface="Calibri" pitchFamily="34" charset="-120"/>
-              </a:rPr>
-              <a:t>5</a:t>
-            </a:r>
-            <a:endParaRPr lang="en-US" sz="1400" dirty="0"/>
-          </a:p>
-        </p:txBody>
-      </p:sp>
     </p:spTree>
   </p:cSld>
   <p:clrMapOvr>
@@ -15768,45 +15339,6 @@
           </a:p>
         </p:txBody>
       </p:sp>
-      <p:sp>
-        <p:nvSpPr>
-          <p:cNvPr id="36" name="Text 34"/>
-          <p:cNvSpPr/>
-          <p:nvPr/>
-        </p:nvSpPr>
-        <p:spPr>
-          <a:xfrm>
-            <a:off x="393192" y="6601968"/>
-            <a:ext cx="539496" cy="182880"/>
-          </a:xfrm>
-          <a:prstGeom prst="rect">
-            <a:avLst/>
-          </a:prstGeom>
-          <a:noFill/>
-          <a:ln/>
-        </p:spPr>
-        <p:txBody>
-          <a:bodyPr wrap="square" rtlCol="0" anchor="ctr"/>
-          <a:lstStyle/>
-          <a:p>
-            <a:pPr algn="l" indent="0" marL="0">
-              <a:buNone/>
-            </a:pPr>
-            <a:r>
-              <a:rPr lang="en-US" sz="1400" b="1" dirty="0">
-                <a:solidFill>
-                  <a:srgbClr val="282629"/>
-                </a:solidFill>
-                <a:latin typeface="Calibri" pitchFamily="34" charset="0"/>
-                <a:ea typeface="Calibri" pitchFamily="34" charset="-122"/>
-                <a:cs typeface="Calibri" pitchFamily="34" charset="-120"/>
-              </a:rPr>
-              <a:t>6</a:t>
-            </a:r>
-            <a:endParaRPr lang="en-US" sz="1400" dirty="0"/>
-          </a:p>
-        </p:txBody>
-      </p:sp>
     </p:spTree>
   </p:cSld>
   <p:clrMapOvr>
@@ -16250,45 +15782,6 @@
           </a:p>
         </p:txBody>
       </p:sp>
-      <p:sp>
-        <p:nvSpPr>
-          <p:cNvPr id="8" name="Text 6"/>
-          <p:cNvSpPr/>
-          <p:nvPr/>
-        </p:nvSpPr>
-        <p:spPr>
-          <a:xfrm>
-            <a:off x="393192" y="6601968"/>
-            <a:ext cx="539496" cy="182880"/>
-          </a:xfrm>
-          <a:prstGeom prst="rect">
-            <a:avLst/>
-          </a:prstGeom>
-          <a:noFill/>
-          <a:ln/>
-        </p:spPr>
-        <p:txBody>
-          <a:bodyPr wrap="square" rtlCol="0" anchor="ctr"/>
-          <a:lstStyle/>
-          <a:p>
-            <a:pPr algn="l" indent="0" marL="0">
-              <a:buNone/>
-            </a:pPr>
-            <a:r>
-              <a:rPr lang="en-US" sz="1400" b="1" dirty="0">
-                <a:solidFill>
-                  <a:srgbClr val="282629"/>
-                </a:solidFill>
-                <a:latin typeface="Calibri" pitchFamily="34" charset="0"/>
-                <a:ea typeface="Calibri" pitchFamily="34" charset="-122"/>
-                <a:cs typeface="Calibri" pitchFamily="34" charset="-120"/>
-              </a:rPr>
-              <a:t>7</a:t>
-            </a:r>
-            <a:endParaRPr lang="en-US" sz="1400" dirty="0"/>
-          </a:p>
-        </p:txBody>
-      </p:sp>
     </p:spTree>
   </p:cSld>
   <p:clrMapOvr>
@@ -16749,45 +16242,6 @@
           </a:p>
         </p:txBody>
       </p:sp>
-      <p:sp>
-        <p:nvSpPr>
-          <p:cNvPr id="8" name="Text 6"/>
-          <p:cNvSpPr/>
-          <p:nvPr/>
-        </p:nvSpPr>
-        <p:spPr>
-          <a:xfrm>
-            <a:off x="393192" y="6601968"/>
-            <a:ext cx="539496" cy="182880"/>
-          </a:xfrm>
-          <a:prstGeom prst="rect">
-            <a:avLst/>
-          </a:prstGeom>
-          <a:noFill/>
-          <a:ln/>
-        </p:spPr>
-        <p:txBody>
-          <a:bodyPr wrap="square" rtlCol="0" anchor="ctr"/>
-          <a:lstStyle/>
-          <a:p>
-            <a:pPr algn="l" indent="0" marL="0">
-              <a:buNone/>
-            </a:pPr>
-            <a:r>
-              <a:rPr lang="en-US" sz="1400" b="1" dirty="0">
-                <a:solidFill>
-                  <a:srgbClr val="282629"/>
-                </a:solidFill>
-                <a:latin typeface="Calibri" pitchFamily="34" charset="0"/>
-                <a:ea typeface="Calibri" pitchFamily="34" charset="-122"/>
-                <a:cs typeface="Calibri" pitchFamily="34" charset="-120"/>
-              </a:rPr>
-              <a:t>8</a:t>
-            </a:r>
-            <a:endParaRPr lang="en-US" sz="1400" dirty="0"/>
-          </a:p>
-        </p:txBody>
-      </p:sp>
     </p:spTree>
   </p:cSld>
   <p:clrMapOvr>
@@ -17257,45 +16711,6 @@
               <a:t>  • 実装コスト・回路サイズの双方を削減</a:t>
             </a:r>
             <a:endParaRPr lang="en-US" sz="1500" dirty="0"/>
-          </a:p>
-        </p:txBody>
-      </p:sp>
-      <p:sp>
-        <p:nvSpPr>
-          <p:cNvPr id="7" name="Text 5"/>
-          <p:cNvSpPr/>
-          <p:nvPr/>
-        </p:nvSpPr>
-        <p:spPr>
-          <a:xfrm>
-            <a:off x="393192" y="6601968"/>
-            <a:ext cx="539496" cy="182880"/>
-          </a:xfrm>
-          <a:prstGeom prst="rect">
-            <a:avLst/>
-          </a:prstGeom>
-          <a:noFill/>
-          <a:ln/>
-        </p:spPr>
-        <p:txBody>
-          <a:bodyPr wrap="square" rtlCol="0" anchor="ctr"/>
-          <a:lstStyle/>
-          <a:p>
-            <a:pPr algn="l" indent="0" marL="0">
-              <a:buNone/>
-            </a:pPr>
-            <a:r>
-              <a:rPr lang="en-US" sz="1400" b="1" dirty="0">
-                <a:solidFill>
-                  <a:srgbClr val="282629"/>
-                </a:solidFill>
-                <a:latin typeface="Calibri" pitchFamily="34" charset="0"/>
-                <a:ea typeface="Calibri" pitchFamily="34" charset="-122"/>
-                <a:cs typeface="Calibri" pitchFamily="34" charset="-120"/>
-              </a:rPr>
-              <a:t>9</a:t>
-            </a:r>
-            <a:endParaRPr lang="en-US" sz="1400" dirty="0"/>
           </a:p>
         </p:txBody>
       </p:sp>

</xml_diff>